<commit_message>
docs(pitch): correcciones de la auditoría previa a la presentación
Retira el 9,8 % de ahorro de los entregables 4 y 6: la corrida del 17-oct
sobre demo-quito-planificacion no lo sostiene (IstpetDev cuesta más que el
calendario fijo semanal). E4 pasa a publicar esa corrida con su lectura.

Guion y láminas: el recorrido sin señal vuelve a figurar como siguiente fase
(no se ha ensayado en teléfono real), «Probado» pasa a «Ensayado», el globo
de Chillo deja de decir que la IA planifica rutas y se quitan de las láminas
los códigos internos (#285, PR, matriz P-xx/A-xx, run n8n).

Unifica la escala en 40 puntos (Quito sintético) y documenta la de la demo
en vivo; corrige los pesos del puntaje A/B/C (35/35/20/10) en E3.

Regenera pitch v7, copia de revisión v8, guion v8 y PDFs de Entregable/.

Co-Authored-By: Claude Sonnet 5.5 <noreply@anthropic.com>
</commit_message>
<xml_diff>
--- a/docs/boveda/Entregable/7-Pitch.pptx
+++ b/docs/boveda/Entregable/7-Pitch.pptx
@@ -3493,7 +3493,7 @@
                 </a:solidFill>
                 <a:latin typeface="Open Sans"/>
               </a:rPr>
-              <a:t>¡Hola! Soy Chillo: usamos </a:t>
+              <a:t>¡Hola! Soy Chillo: el motor </a:t>
             </a:r>
             <a:r>
               <a:rPr sz="1500" b="1" i="0">
@@ -3502,7 +3502,7 @@
                 </a:solidFill>
                 <a:latin typeface="Open Sans"/>
               </a:rPr>
-              <a:t>IA para planificar rutas</a:t>
+              <a:t>calcula y la IA explica</a:t>
             </a:r>
             <a:r>
               <a:rPr sz="1500" b="1" i="0">
@@ -3511,7 +3511,7 @@
                 </a:solidFill>
                 <a:latin typeface="Open Sans"/>
               </a:rPr>
-              <a:t> y llegar antes que la llamada.</a:t>
+              <a:t> para llegar antes que la llamada.</a:t>
             </a:r>
           </a:p>
         </p:txBody>
@@ -4178,7 +4178,7 @@
                 </a:solidFill>
                 <a:latin typeface="Open Sans"/>
               </a:rPr>
-              <a:t>Fuente: ensayo técnico #285 (demo-quito-planificacion): 4 pedidos, 6 entregas críticas; opciones A, B y C de 02-suggest-pitch-abc.json · matriz P-02, P-04, P-05. Escenario sintético: no son clientes ni operaciones medidas.</a:t>
+              <a:t>Fuente: ensayo técnico del motor sobre un escenario sintético de Quito: 4 pedidos, 6 entregas críticas, opciones A, B y C. No son clientes ni operaciones medidas.</a:t>
             </a:r>
           </a:p>
         </p:txBody>
@@ -6938,7 +6938,7 @@
                 </a:solidFill>
                 <a:latin typeface="Open Sans"/>
               </a:rPr>
-              <a:t>Fuente: ensayo técnico #285 (PR #295, 1585ab7), 02-suggest-pitch-abc.json · demo-quito-planificacion, corrida local 17-oct · 4 pedidos, 6 entregas críticas, 55,9 km · diésel USD 3,11/gal (Primicias, 12-oct) · matriz P-02.</a:t>
+              <a:t>Fuente: ensayo técnico local del motor, 17-oct · escenario sintético de Quito · 4 pedidos, 6 entregas críticas, 55,9 km · diésel USD 3,11/gal (Primicias, 12-oct). Una sola corrida, sin clientes reales.</a:t>
             </a:r>
           </a:p>
         </p:txBody>
@@ -10823,7 +10823,7 @@
                 </a:solidFill>
                 <a:latin typeface="Open Sans"/>
               </a:rPr>
-              <a:t>Fuente: matriz A-02 (hipótesis del sector), A-06, A-08, A-10, A-11 y A-12 (run n8n 292, respaldo sin IA). Lo del sector es lo que escuchamos, no una medición.</a:t>
+              <a:t>Fuente: lo del sector es lo que escuchamos en la charla, no una medición. Una corrida registrada del agente incluyó su caída a la explicación de respaldo.</a:t>
             </a:r>
           </a:p>
         </p:txBody>
@@ -11958,7 +11958,7 @@
                 </a:solidFill>
                 <a:latin typeface="Open Sans"/>
               </a:rPr>
-              <a:t>Fuente: matriz de afirmaciones P-02, P-04, P-05, A-03, A-11, A-12, A-13, A-15, A-21 y #198. Escenario sintético de Quito: 40 puntos, no son clientes.</a:t>
+              <a:t>Fuente: escenario sintético de Quito: 40 puntos, no son clientes. El recorrido sin señal está construido y aún no se ensayó en un teléfono real.</a:t>
             </a:r>
           </a:p>
         </p:txBody>
@@ -12280,7 +12280,7 @@
                   </a:solidFill>
                   <a:latin typeface="Oswald"/>
                 </a:rPr>
-                <a:t>PROBADO</a:t>
+                <a:t>ENSAYADO</a:t>
               </a:r>
             </a:p>
           </p:txBody>
@@ -12498,6 +12498,25 @@
                   <a:latin typeface="Open Sans"/>
                 </a:rPr>
                 <a:t>•  Usarlo en una empresa real: cargar sus datos y medir contra su línea base</a:t>
+              </a:r>
+            </a:p>
+            <a:p>
+              <a:pPr algn="l">
+                <a:lnSpc>
+                  <a:spcPct val="105000"/>
+                </a:lnSpc>
+                <a:spcAft>
+                  <a:spcPts val="800"/>
+                </a:spcAft>
+              </a:pPr>
+              <a:r>
+                <a:rPr sz="1550" b="1" i="0">
+                  <a:solidFill>
+                    <a:srgbClr val="E6D7A3"/>
+                  </a:solidFill>
+                  <a:latin typeface="Open Sans"/>
+                </a:rPr>
+                <a:t>•  Probar el recorrido sin señal en un teléfono real</a:t>
               </a:r>
             </a:p>
             <a:p>
@@ -13159,7 +13178,7 @@
                 </a:solidFill>
                 <a:latin typeface="Open Sans"/>
               </a:rPr>
-              <a:t>Fuente: matriz A-21 (sin ahorro prometido), A-26 y A-30 (costo y precio por validar), A-31 (modelo), P-07 (indicadores en curso); pantalla Reportes (código en develop, sin ensayo de la escena). Sujeto a validación.</a:t>
+              <a:t>Fuente: sin ahorro prometido; costo y precio por validar en el piloto; modelo como hipótesis. La sección Reportes existe en el sistema, sin ensayo de la escena.</a:t>
             </a:r>
           </a:p>
         </p:txBody>
@@ -14707,7 +14726,7 @@
                 </a:solidFill>
                 <a:latin typeface="Open Sans"/>
               </a:rPr>
-              <a:t>Fuente: matriz A-21, A-32 y P-02. Propuesta sin contraparte confirmada; sujeta a validación.</a:t>
+              <a:t>Fuente: propuesta sin contraparte confirmada ni cliente comprometido; sujeta a validación.</a:t>
             </a:r>
           </a:p>
         </p:txBody>

</xml_diff>

<commit_message>
docs(pitch): correcciones de la auditoría previa a la presentación (#373)
Retira el 9,8 % de ahorro de los entregables 4 y 6: la corrida del 17-oct
sobre demo-quito-planificacion no lo sostiene (IstpetDev cuesta más que el
calendario fijo semanal). E4 pasa a publicar esa corrida con su lectura.

Guion y láminas: el recorrido sin señal vuelve a figurar como siguiente fase
(no se ha ensayado en teléfono real), «Probado» pasa a «Ensayado», el globo
de Chillo deja de decir que la IA planifica rutas y se quitan de las láminas
los códigos internos (#285, PR, matriz P-xx/A-xx, run n8n).

Unifica la escala en 40 puntos (Quito sintético) y documenta la de la demo
en vivo; corrige los pesos del puntaje A/B/C (35/35/20/10) en E3.

Regenera pitch v7, copia de revisión v8, guion v8 y PDFs de Entregable/.

Co-authored-by: Claude Sonnet 5.5 <noreply@anthropic.com>
</commit_message>
<xml_diff>
--- a/docs/boveda/Entregable/7-Pitch.pptx
+++ b/docs/boveda/Entregable/7-Pitch.pptx
@@ -3493,7 +3493,7 @@
                 </a:solidFill>
                 <a:latin typeface="Open Sans"/>
               </a:rPr>
-              <a:t>¡Hola! Soy Chillo: usamos </a:t>
+              <a:t>¡Hola! Soy Chillo: el motor </a:t>
             </a:r>
             <a:r>
               <a:rPr sz="1500" b="1" i="0">
@@ -3502,7 +3502,7 @@
                 </a:solidFill>
                 <a:latin typeface="Open Sans"/>
               </a:rPr>
-              <a:t>IA para planificar rutas</a:t>
+              <a:t>calcula y la IA explica</a:t>
             </a:r>
             <a:r>
               <a:rPr sz="1500" b="1" i="0">
@@ -3511,7 +3511,7 @@
                 </a:solidFill>
                 <a:latin typeface="Open Sans"/>
               </a:rPr>
-              <a:t> y llegar antes que la llamada.</a:t>
+              <a:t> para llegar antes que la llamada.</a:t>
             </a:r>
           </a:p>
         </p:txBody>
@@ -4178,7 +4178,7 @@
                 </a:solidFill>
                 <a:latin typeface="Open Sans"/>
               </a:rPr>
-              <a:t>Fuente: ensayo técnico #285 (demo-quito-planificacion): 4 pedidos, 6 entregas críticas; opciones A, B y C de 02-suggest-pitch-abc.json · matriz P-02, P-04, P-05. Escenario sintético: no son clientes ni operaciones medidas.</a:t>
+              <a:t>Fuente: ensayo técnico del motor sobre un escenario sintético de Quito: 4 pedidos, 6 entregas críticas, opciones A, B y C. No son clientes ni operaciones medidas.</a:t>
             </a:r>
           </a:p>
         </p:txBody>
@@ -6938,7 +6938,7 @@
                 </a:solidFill>
                 <a:latin typeface="Open Sans"/>
               </a:rPr>
-              <a:t>Fuente: ensayo técnico #285 (PR #295, 1585ab7), 02-suggest-pitch-abc.json · demo-quito-planificacion, corrida local 17-oct · 4 pedidos, 6 entregas críticas, 55,9 km · diésel USD 3,11/gal (Primicias, 12-oct) · matriz P-02.</a:t>
+              <a:t>Fuente: ensayo técnico local del motor, 17-oct · escenario sintético de Quito · 4 pedidos, 6 entregas críticas, 55,9 km · diésel USD 3,11/gal (Primicias, 12-oct). Una sola corrida, sin clientes reales.</a:t>
             </a:r>
           </a:p>
         </p:txBody>
@@ -10823,7 +10823,7 @@
                 </a:solidFill>
                 <a:latin typeface="Open Sans"/>
               </a:rPr>
-              <a:t>Fuente: matriz A-02 (hipótesis del sector), A-06, A-08, A-10, A-11 y A-12 (run n8n 292, respaldo sin IA). Lo del sector es lo que escuchamos, no una medición.</a:t>
+              <a:t>Fuente: lo del sector es lo que escuchamos en la charla, no una medición. Una corrida registrada del agente incluyó su caída a la explicación de respaldo.</a:t>
             </a:r>
           </a:p>
         </p:txBody>
@@ -11958,7 +11958,7 @@
                 </a:solidFill>
                 <a:latin typeface="Open Sans"/>
               </a:rPr>
-              <a:t>Fuente: matriz de afirmaciones P-02, P-04, P-05, A-03, A-11, A-12, A-13, A-15, A-21 y #198. Escenario sintético de Quito: 40 puntos, no son clientes.</a:t>
+              <a:t>Fuente: escenario sintético de Quito: 40 puntos, no son clientes. El recorrido sin señal está construido y aún no se ensayó en un teléfono real.</a:t>
             </a:r>
           </a:p>
         </p:txBody>
@@ -12280,7 +12280,7 @@
                   </a:solidFill>
                   <a:latin typeface="Oswald"/>
                 </a:rPr>
-                <a:t>PROBADO</a:t>
+                <a:t>ENSAYADO</a:t>
               </a:r>
             </a:p>
           </p:txBody>
@@ -12498,6 +12498,25 @@
                   <a:latin typeface="Open Sans"/>
                 </a:rPr>
                 <a:t>•  Usarlo en una empresa real: cargar sus datos y medir contra su línea base</a:t>
+              </a:r>
+            </a:p>
+            <a:p>
+              <a:pPr algn="l">
+                <a:lnSpc>
+                  <a:spcPct val="105000"/>
+                </a:lnSpc>
+                <a:spcAft>
+                  <a:spcPts val="800"/>
+                </a:spcAft>
+              </a:pPr>
+              <a:r>
+                <a:rPr sz="1550" b="1" i="0">
+                  <a:solidFill>
+                    <a:srgbClr val="E6D7A3"/>
+                  </a:solidFill>
+                  <a:latin typeface="Open Sans"/>
+                </a:rPr>
+                <a:t>•  Probar el recorrido sin señal en un teléfono real</a:t>
               </a:r>
             </a:p>
             <a:p>
@@ -13159,7 +13178,7 @@
                 </a:solidFill>
                 <a:latin typeface="Open Sans"/>
               </a:rPr>
-              <a:t>Fuente: matriz A-21 (sin ahorro prometido), A-26 y A-30 (costo y precio por validar), A-31 (modelo), P-07 (indicadores en curso); pantalla Reportes (código en develop, sin ensayo de la escena). Sujeto a validación.</a:t>
+              <a:t>Fuente: sin ahorro prometido; costo y precio por validar en el piloto; modelo como hipótesis. La sección Reportes existe en el sistema, sin ensayo de la escena.</a:t>
             </a:r>
           </a:p>
         </p:txBody>
@@ -14707,7 +14726,7 @@
                 </a:solidFill>
                 <a:latin typeface="Open Sans"/>
               </a:rPr>
-              <a:t>Fuente: matriz A-21, A-32 y P-02. Propuesta sin contraparte confirmada; sujeta a validación.</a:t>
+              <a:t>Fuente: propuesta sin contraparte confirmada ni cliente comprometido; sujeta a validación.</a:t>
             </a:r>
           </a:p>
         </p:txBody>

</xml_diff>

<commit_message>
docs(entregable): pitch v8 de 10 láminas con la cuenta del jurado
Entregable/7-Pitch.* pasa de la v7 (9 láminas) a la v8 con la lámina 10
(QR, cuenta Auditor y seguridad). Por decisión del equipo lleva la clave del
jurado en la última lámina; la cuenta es de solo lectura y debe
desactivarse al terminar la evaluación. 8-Guion-del-pitch.pdf pasa al guion
v8 (sin clave). Se actualiza la documentación que decía lo contrario.

Co-Authored-By: Claude Sonnet 5.5 <noreply@anthropic.com>
</commit_message>
<xml_diff>
--- a/docs/boveda/Entregable/7-Pitch.pptx
+++ b/docs/boveda/Entregable/7-Pitch.pptx
@@ -14,6 +14,7 @@
     <p:sldId id="262" r:id="rId13"/>
     <p:sldId id="263" r:id="rId14"/>
     <p:sldId id="264" r:id="rId15"/>
+    <p:sldId id="265" r:id="rId16"/>
   </p:sldIdLst>
   <p:sldSz cx="12191695" cy="6858000" type="screen4x3"/>
   <p:notesSz cx="6858000" cy="9144000"/>
@@ -113,6 +114,1106 @@
     </a:lvl9pPr>
   </p:defaultTextStyle>
 </p:presentation>
+</file>
+
+<file path=ppt/notesMasters/notesMaster1.xml><?xml version="1.0" encoding="utf-8"?>
+<p:notesMaster xmlns:a="http://schemas.openxmlformats.org/drawingml/2006/main" xmlns:p="http://schemas.openxmlformats.org/presentationml/2006/main" xmlns:r="http://schemas.openxmlformats.org/officeDocument/2006/relationships">
+  <p:cSld>
+    <p:bg>
+      <p:bgRef idx="1001">
+        <a:schemeClr val="bg1"/>
+      </p:bgRef>
+    </p:bg>
+    <p:spTree>
+      <p:nvGrpSpPr>
+        <p:cNvPr id="1" name=""/>
+        <p:cNvGrpSpPr/>
+        <p:nvPr/>
+      </p:nvGrpSpPr>
+      <p:grpSpPr>
+        <a:xfrm>
+          <a:off x="0" y="0"/>
+          <a:ext cx="0" cy="0"/>
+          <a:chOff x="0" y="0"/>
+          <a:chExt cx="0" cy="0"/>
+        </a:xfrm>
+      </p:grpSpPr>
+      <p:sp>
+        <p:nvSpPr>
+          <p:cNvPr id="2" name="Header Placeholder 1"/>
+          <p:cNvSpPr>
+            <a:spLocks noGrp="1"/>
+          </p:cNvSpPr>
+          <p:nvPr>
+            <p:ph type="hdr" sz="quarter"/>
+          </p:nvPr>
+        </p:nvSpPr>
+        <p:spPr>
+          <a:xfrm>
+            <a:off x="0" y="0"/>
+            <a:ext cx="2971800" cy="457200"/>
+          </a:xfrm>
+          <a:prstGeom prst="rect">
+            <a:avLst/>
+          </a:prstGeom>
+        </p:spPr>
+        <p:txBody>
+          <a:bodyPr vert="horz" lIns="91440" tIns="45720" rIns="91440" bIns="45720" rtlCol="0"/>
+          <a:lstStyle>
+            <a:lvl1pPr algn="l">
+              <a:defRPr sz="1200"/>
+            </a:lvl1pPr>
+          </a:lstStyle>
+          <a:p>
+            <a:endParaRPr lang="en-US"/>
+          </a:p>
+        </p:txBody>
+      </p:sp>
+      <p:sp>
+        <p:nvSpPr>
+          <p:cNvPr id="3" name="Date Placeholder 2"/>
+          <p:cNvSpPr>
+            <a:spLocks noGrp="1"/>
+          </p:cNvSpPr>
+          <p:nvPr>
+            <p:ph type="dt" idx="1"/>
+          </p:nvPr>
+        </p:nvSpPr>
+        <p:spPr>
+          <a:xfrm>
+            <a:off x="3884613" y="0"/>
+            <a:ext cx="2971800" cy="457200"/>
+          </a:xfrm>
+          <a:prstGeom prst="rect">
+            <a:avLst/>
+          </a:prstGeom>
+        </p:spPr>
+        <p:txBody>
+          <a:bodyPr vert="horz" lIns="91440" tIns="45720" rIns="91440" bIns="45720" rtlCol="0"/>
+          <a:lstStyle>
+            <a:lvl1pPr algn="r">
+              <a:defRPr sz="1200"/>
+            </a:lvl1pPr>
+          </a:lstStyle>
+          <a:p>
+            <a:fld id="{0F89C1C7-3DCD-1040-A9CF-14679D8B5DDD}" type="datetimeFigureOut">
+              <a:rPr lang="en-US" smtClean="0"/>
+              <a:t>10/17/16</a:t>
+            </a:fld>
+            <a:endParaRPr lang="en-US"/>
+          </a:p>
+        </p:txBody>
+      </p:sp>
+      <p:sp>
+        <p:nvSpPr>
+          <p:cNvPr id="4" name="Slide Image Placeholder 3"/>
+          <p:cNvSpPr>
+            <a:spLocks noGrp="1" noRot="1" noChangeAspect="1"/>
+          </p:cNvSpPr>
+          <p:nvPr>
+            <p:ph type="sldImg" idx="2"/>
+          </p:nvPr>
+        </p:nvSpPr>
+        <p:spPr>
+          <a:xfrm>
+            <a:off x="1143000" y="685800"/>
+            <a:ext cx="4572000" cy="3429000"/>
+          </a:xfrm>
+          <a:prstGeom prst="rect">
+            <a:avLst/>
+          </a:prstGeom>
+          <a:noFill/>
+          <a:ln w="12700">
+            <a:solidFill>
+              <a:prstClr val="black"/>
+            </a:solidFill>
+          </a:ln>
+        </p:spPr>
+        <p:txBody>
+          <a:bodyPr vert="horz" lIns="91440" tIns="45720" rIns="91440" bIns="45720" rtlCol="0" anchor="ctr"/>
+          <a:lstStyle/>
+          <a:p>
+            <a:endParaRPr lang="en-US"/>
+          </a:p>
+        </p:txBody>
+      </p:sp>
+      <p:sp>
+        <p:nvSpPr>
+          <p:cNvPr id="5" name="Notes Placeholder 4"/>
+          <p:cNvSpPr>
+            <a:spLocks noGrp="1"/>
+          </p:cNvSpPr>
+          <p:nvPr>
+            <p:ph type="body" sz="quarter" idx="3"/>
+          </p:nvPr>
+        </p:nvSpPr>
+        <p:spPr>
+          <a:xfrm>
+            <a:off x="685800" y="4343400"/>
+            <a:ext cx="5486400" cy="4114800"/>
+          </a:xfrm>
+          <a:prstGeom prst="rect">
+            <a:avLst/>
+          </a:prstGeom>
+        </p:spPr>
+        <p:txBody>
+          <a:bodyPr vert="horz" lIns="91440" tIns="45720" rIns="91440" bIns="45720" rtlCol="0"/>
+          <a:lstStyle/>
+          <a:p>
+            <a:pPr lvl="0"/>
+            <a:r>
+              <a:rPr lang="en-US" smtClean="0"/>
+              <a:t>Click to edit Master text styles</a:t>
+            </a:r>
+          </a:p>
+          <a:p>
+            <a:pPr lvl="1"/>
+            <a:r>
+              <a:rPr lang="en-US" smtClean="0"/>
+              <a:t>Second level</a:t>
+            </a:r>
+          </a:p>
+          <a:p>
+            <a:pPr lvl="2"/>
+            <a:r>
+              <a:rPr lang="en-US" smtClean="0"/>
+              <a:t>Third level</a:t>
+            </a:r>
+          </a:p>
+          <a:p>
+            <a:pPr lvl="3"/>
+            <a:r>
+              <a:rPr lang="en-US" smtClean="0"/>
+              <a:t>Fourth level</a:t>
+            </a:r>
+          </a:p>
+          <a:p>
+            <a:pPr lvl="4"/>
+            <a:r>
+              <a:rPr lang="en-US" smtClean="0"/>
+              <a:t>Fifth level</a:t>
+            </a:r>
+            <a:endParaRPr lang="en-US"/>
+          </a:p>
+        </p:txBody>
+      </p:sp>
+      <p:sp>
+        <p:nvSpPr>
+          <p:cNvPr id="6" name="Footer Placeholder 5"/>
+          <p:cNvSpPr>
+            <a:spLocks noGrp="1"/>
+          </p:cNvSpPr>
+          <p:nvPr>
+            <p:ph type="ftr" sz="quarter" idx="4"/>
+          </p:nvPr>
+        </p:nvSpPr>
+        <p:spPr>
+          <a:xfrm>
+            <a:off x="0" y="8685213"/>
+            <a:ext cx="2971800" cy="457200"/>
+          </a:xfrm>
+          <a:prstGeom prst="rect">
+            <a:avLst/>
+          </a:prstGeom>
+        </p:spPr>
+        <p:txBody>
+          <a:bodyPr vert="horz" lIns="91440" tIns="45720" rIns="91440" bIns="45720" rtlCol="0" anchor="b"/>
+          <a:lstStyle>
+            <a:lvl1pPr algn="l">
+              <a:defRPr sz="1200"/>
+            </a:lvl1pPr>
+          </a:lstStyle>
+          <a:p>
+            <a:endParaRPr lang="en-US"/>
+          </a:p>
+        </p:txBody>
+      </p:sp>
+      <p:sp>
+        <p:nvSpPr>
+          <p:cNvPr id="7" name="Slide Number Placeholder 6"/>
+          <p:cNvSpPr>
+            <a:spLocks noGrp="1"/>
+          </p:cNvSpPr>
+          <p:nvPr>
+            <p:ph type="sldNum" sz="quarter" idx="5"/>
+          </p:nvPr>
+        </p:nvSpPr>
+        <p:spPr>
+          <a:xfrm>
+            <a:off x="3884613" y="8685213"/>
+            <a:ext cx="2971800" cy="457200"/>
+          </a:xfrm>
+          <a:prstGeom prst="rect">
+            <a:avLst/>
+          </a:prstGeom>
+        </p:spPr>
+        <p:txBody>
+          <a:bodyPr vert="horz" lIns="91440" tIns="45720" rIns="91440" bIns="45720" rtlCol="0" anchor="b"/>
+          <a:lstStyle>
+            <a:lvl1pPr algn="r">
+              <a:defRPr sz="1200"/>
+            </a:lvl1pPr>
+          </a:lstStyle>
+          <a:p>
+            <a:fld id="{BB5E49A5-4136-284D-997B-48E1D791AD67}" type="slidenum">
+              <a:rPr lang="en-US" smtClean="0"/>
+              <a:t>‹#›</a:t>
+            </a:fld>
+            <a:endParaRPr lang="en-US"/>
+          </a:p>
+        </p:txBody>
+      </p:sp>
+    </p:spTree>
+    <p:extLst>
+      <p:ext uri="{BB962C8B-B14F-4D97-AF65-F5344CB8AC3E}">
+        <p14:creationId xmlns:p14="http://schemas.microsoft.com/office/powerpoint/2010/main" val="2623252185"/>
+      </p:ext>
+    </p:extLst>
+  </p:cSld>
+  <p:clrMap bg1="lt1" tx1="dk1" bg2="lt2" tx2="dk2" accent1="accent1" accent2="accent2" accent3="accent3" accent4="accent4" accent5="accent5" accent6="accent6" hlink="hlink" folHlink="folHlink"/>
+  <p:notesStyle>
+    <a:lvl1pPr marL="0" algn="l" defTabSz="457200" rtl="0" eaLnBrk="1" latinLnBrk="0" hangingPunct="1">
+      <a:defRPr sz="1200" kern="1200">
+        <a:solidFill>
+          <a:schemeClr val="tx1"/>
+        </a:solidFill>
+        <a:latin typeface="+mn-lt"/>
+        <a:ea typeface="+mn-ea"/>
+        <a:cs typeface="+mn-cs"/>
+      </a:defRPr>
+    </a:lvl1pPr>
+    <a:lvl2pPr marL="457200" algn="l" defTabSz="457200" rtl="0" eaLnBrk="1" latinLnBrk="0" hangingPunct="1">
+      <a:defRPr sz="1200" kern="1200">
+        <a:solidFill>
+          <a:schemeClr val="tx1"/>
+        </a:solidFill>
+        <a:latin typeface="+mn-lt"/>
+        <a:ea typeface="+mn-ea"/>
+        <a:cs typeface="+mn-cs"/>
+      </a:defRPr>
+    </a:lvl2pPr>
+    <a:lvl3pPr marL="914400" algn="l" defTabSz="457200" rtl="0" eaLnBrk="1" latinLnBrk="0" hangingPunct="1">
+      <a:defRPr sz="1200" kern="1200">
+        <a:solidFill>
+          <a:schemeClr val="tx1"/>
+        </a:solidFill>
+        <a:latin typeface="+mn-lt"/>
+        <a:ea typeface="+mn-ea"/>
+        <a:cs typeface="+mn-cs"/>
+      </a:defRPr>
+    </a:lvl3pPr>
+    <a:lvl4pPr marL="1371600" algn="l" defTabSz="457200" rtl="0" eaLnBrk="1" latinLnBrk="0" hangingPunct="1">
+      <a:defRPr sz="1200" kern="1200">
+        <a:solidFill>
+          <a:schemeClr val="tx1"/>
+        </a:solidFill>
+        <a:latin typeface="+mn-lt"/>
+        <a:ea typeface="+mn-ea"/>
+        <a:cs typeface="+mn-cs"/>
+      </a:defRPr>
+    </a:lvl4pPr>
+    <a:lvl5pPr marL="1828800" algn="l" defTabSz="457200" rtl="0" eaLnBrk="1" latinLnBrk="0" hangingPunct="1">
+      <a:defRPr sz="1200" kern="1200">
+        <a:solidFill>
+          <a:schemeClr val="tx1"/>
+        </a:solidFill>
+        <a:latin typeface="+mn-lt"/>
+        <a:ea typeface="+mn-ea"/>
+        <a:cs typeface="+mn-cs"/>
+      </a:defRPr>
+    </a:lvl5pPr>
+    <a:lvl6pPr marL="2286000" algn="l" defTabSz="457200" rtl="0" eaLnBrk="1" latinLnBrk="0" hangingPunct="1">
+      <a:defRPr sz="1200" kern="1200">
+        <a:solidFill>
+          <a:schemeClr val="tx1"/>
+        </a:solidFill>
+        <a:latin typeface="+mn-lt"/>
+        <a:ea typeface="+mn-ea"/>
+        <a:cs typeface="+mn-cs"/>
+      </a:defRPr>
+    </a:lvl6pPr>
+    <a:lvl7pPr marL="2743200" algn="l" defTabSz="457200" rtl="0" eaLnBrk="1" latinLnBrk="0" hangingPunct="1">
+      <a:defRPr sz="1200" kern="1200">
+        <a:solidFill>
+          <a:schemeClr val="tx1"/>
+        </a:solidFill>
+        <a:latin typeface="+mn-lt"/>
+        <a:ea typeface="+mn-ea"/>
+        <a:cs typeface="+mn-cs"/>
+      </a:defRPr>
+    </a:lvl7pPr>
+    <a:lvl8pPr marL="3200400" algn="l" defTabSz="457200" rtl="0" eaLnBrk="1" latinLnBrk="0" hangingPunct="1">
+      <a:defRPr sz="1200" kern="1200">
+        <a:solidFill>
+          <a:schemeClr val="tx1"/>
+        </a:solidFill>
+        <a:latin typeface="+mn-lt"/>
+        <a:ea typeface="+mn-ea"/>
+        <a:cs typeface="+mn-cs"/>
+      </a:defRPr>
+    </a:lvl8pPr>
+    <a:lvl9pPr marL="3657600" algn="l" defTabSz="457200" rtl="0" eaLnBrk="1" latinLnBrk="0" hangingPunct="1">
+      <a:defRPr sz="1200" kern="1200">
+        <a:solidFill>
+          <a:schemeClr val="tx1"/>
+        </a:solidFill>
+        <a:latin typeface="+mn-lt"/>
+        <a:ea typeface="+mn-ea"/>
+        <a:cs typeface="+mn-cs"/>
+      </a:defRPr>
+    </a:lvl9pPr>
+  </p:notesStyle>
+</p:notesMaster>
+</file>
+
+<file path=ppt/notesSlides/notesSlide1.xml><?xml version="1.0" encoding="utf-8"?>
+<p:notes xmlns:a="http://schemas.openxmlformats.org/drawingml/2006/main" xmlns:p="http://schemas.openxmlformats.org/presentationml/2006/main" xmlns:r="http://schemas.openxmlformats.org/officeDocument/2006/relationships">
+  <p:cSld>
+    <p:spTree>
+      <p:nvGrpSpPr>
+        <p:cNvPr id="1" name=""/>
+        <p:cNvGrpSpPr/>
+        <p:nvPr/>
+      </p:nvGrpSpPr>
+      <p:grpSpPr>
+        <a:xfrm>
+          <a:off x="0" y="0"/>
+          <a:ext cx="0" cy="0"/>
+          <a:chOff x="0" y="0"/>
+          <a:chExt cx="0" cy="0"/>
+        </a:xfrm>
+      </p:grpSpPr>
+      <p:sp>
+        <p:nvSpPr>
+          <p:cNvPr id="2" name="Slide Image Placeholder 1"/>
+          <p:cNvSpPr>
+            <a:spLocks noGrp="1"/>
+          </p:cNvSpPr>
+          <p:nvPr>
+            <p:ph type="sldImg" idx="2"/>
+          </p:nvPr>
+        </p:nvSpPr>
+        <p:spPr/>
+      </p:sp>
+      <p:sp>
+        <p:nvSpPr>
+          <p:cNvPr id="3" name="Notes Placeholder 2"/>
+          <p:cNvSpPr>
+            <a:spLocks noGrp="1"/>
+          </p:cNvSpPr>
+          <p:nvPr>
+            <p:ph type="body" idx="3" sz="quarter"/>
+          </p:nvPr>
+        </p:nvSpPr>
+        <p:spPr/>
+        <p:txBody>
+          <a:bodyPr/>
+          <a:lstStyle/>
+          <a:p>
+            <a:r>
+              <a:t>Joseph · 15 s</a:t>
+            </a:r>
+          </a:p>
+          <a:p>
+            <a:r>
+              <a:t>¿Cómo se entera hoy una empresa de limpieza de que a un hospital le falta desinfectante? Cuando el hospital llama. Ese día ya es tarde.</a:t>
+            </a:r>
+          </a:p>
+        </p:txBody>
+      </p:sp>
+      <p:sp>
+        <p:nvSpPr>
+          <p:cNvPr id="4" name="Slide Number Placeholder 3"/>
+          <p:cNvSpPr>
+            <a:spLocks noGrp="1"/>
+          </p:cNvSpPr>
+          <p:nvPr>
+            <p:ph type="sldNum" idx="5" sz="quarter"/>
+          </p:nvPr>
+        </p:nvSpPr>
+        <p:spPr/>
+      </p:sp>
+    </p:spTree>
+  </p:cSld>
+  <p:clrMapOvr>
+    <a:masterClrMapping/>
+  </p:clrMapOvr>
+</p:notes>
+</file>
+
+<file path=ppt/notesSlides/notesSlide10.xml><?xml version="1.0" encoding="utf-8"?>
+<p:notes xmlns:a="http://schemas.openxmlformats.org/drawingml/2006/main" xmlns:p="http://schemas.openxmlformats.org/presentationml/2006/main" xmlns:r="http://schemas.openxmlformats.org/officeDocument/2006/relationships">
+  <p:cSld>
+    <p:spTree>
+      <p:nvGrpSpPr>
+        <p:cNvPr id="1" name=""/>
+        <p:cNvGrpSpPr/>
+        <p:nvPr/>
+      </p:nvGrpSpPr>
+      <p:grpSpPr>
+        <a:xfrm>
+          <a:off x="0" y="0"/>
+          <a:ext cx="0" cy="0"/>
+          <a:chOff x="0" y="0"/>
+          <a:chExt cx="0" cy="0"/>
+        </a:xfrm>
+      </p:grpSpPr>
+      <p:sp>
+        <p:nvSpPr>
+          <p:cNvPr id="2" name="Slide Image Placeholder 1"/>
+          <p:cNvSpPr>
+            <a:spLocks noGrp="1"/>
+          </p:cNvSpPr>
+          <p:nvPr>
+            <p:ph type="sldImg" idx="2"/>
+          </p:nvPr>
+        </p:nvSpPr>
+        <p:spPr/>
+      </p:sp>
+      <p:sp>
+        <p:nvSpPr>
+          <p:cNvPr id="3" name="Notes Placeholder 2"/>
+          <p:cNvSpPr>
+            <a:spLocks noGrp="1"/>
+          </p:cNvSpPr>
+          <p:nvPr>
+            <p:ph type="body" idx="3" sz="quarter"/>
+          </p:nvPr>
+        </p:nvSpPr>
+        <p:spPr/>
+        <p:txBody>
+          <a:bodyPr/>
+          <a:lstStyle/>
+          <a:p>
+            <a:r>
+              <a:t>Bryan · 20 s</a:t>
+            </a:r>
+          </a:p>
+          <a:p>
+            <a:r>
+              <a:t>Escaneen el QR y entren con este usuario y clave. El acceso usa AWS Cognito en la nube de Amazon, con conexión cifrada. Entran como auditores: pueden ver todo el sistema sin modificar datos. Dejamos la pantalla para sus preguntas.</a:t>
+            </a:r>
+          </a:p>
+        </p:txBody>
+      </p:sp>
+      <p:sp>
+        <p:nvSpPr>
+          <p:cNvPr id="4" name="Slide Number Placeholder 3"/>
+          <p:cNvSpPr>
+            <a:spLocks noGrp="1"/>
+          </p:cNvSpPr>
+          <p:nvPr>
+            <p:ph type="sldNum" idx="5" sz="quarter"/>
+          </p:nvPr>
+        </p:nvSpPr>
+        <p:spPr/>
+      </p:sp>
+    </p:spTree>
+  </p:cSld>
+  <p:clrMapOvr>
+    <a:masterClrMapping/>
+  </p:clrMapOvr>
+</p:notes>
+</file>
+
+<file path=ppt/notesSlides/notesSlide2.xml><?xml version="1.0" encoding="utf-8"?>
+<p:notes xmlns:a="http://schemas.openxmlformats.org/drawingml/2006/main" xmlns:p="http://schemas.openxmlformats.org/presentationml/2006/main" xmlns:r="http://schemas.openxmlformats.org/officeDocument/2006/relationships">
+  <p:cSld>
+    <p:spTree>
+      <p:nvGrpSpPr>
+        <p:cNvPr id="1" name=""/>
+        <p:cNvGrpSpPr/>
+        <p:nvPr/>
+      </p:nvGrpSpPr>
+      <p:grpSpPr>
+        <a:xfrm>
+          <a:off x="0" y="0"/>
+          <a:ext cx="0" cy="0"/>
+          <a:chOff x="0" y="0"/>
+          <a:chExt cx="0" cy="0"/>
+        </a:xfrm>
+      </p:grpSpPr>
+      <p:sp>
+        <p:nvSpPr>
+          <p:cNvPr id="2" name="Slide Image Placeholder 1"/>
+          <p:cNvSpPr>
+            <a:spLocks noGrp="1"/>
+          </p:cNvSpPr>
+          <p:nvPr>
+            <p:ph type="sldImg" idx="2"/>
+          </p:nvPr>
+        </p:nvSpPr>
+        <p:spPr/>
+      </p:sp>
+      <p:sp>
+        <p:nvSpPr>
+          <p:cNvPr id="3" name="Notes Placeholder 2"/>
+          <p:cNvSpPr>
+            <a:spLocks noGrp="1"/>
+          </p:cNvSpPr>
+          <p:nvPr>
+            <p:ph type="body" idx="3" sz="quarter"/>
+          </p:nvPr>
+        </p:nvSpPr>
+        <p:spPr/>
+        <p:txBody>
+          <a:bodyPr/>
+          <a:lstStyle/>
+          <a:p>
+            <a:r>
+              <a:t>Joseph · 40 s</a:t>
+            </a:r>
+          </a:p>
+          <a:p>
+            <a:r>
+              <a:t>Pongámonos en un día cualquiera, en nuestro escenario de Quito, que es sintético. Cuatro pedidos, con seis entregas críticas, entre hospitales y otros clientes, necesitan insumos de limpieza hoy. Hay tres maneras de atenderlos. A: un solo viaje con flota propia. B: también flota propia, pero los críticos primero, en el primer turno. C: contratar un operador externo. Hoy esa decisión se toma mirando kilómetros. Pero lo que cuesta de verdad es el personal, el combustible, la descarga y el producto que se daña. Y lo que importa: que lo crítico llegue a tiempo.</a:t>
+            </a:r>
+          </a:p>
+        </p:txBody>
+      </p:sp>
+      <p:sp>
+        <p:nvSpPr>
+          <p:cNvPr id="4" name="Slide Number Placeholder 3"/>
+          <p:cNvSpPr>
+            <a:spLocks noGrp="1"/>
+          </p:cNvSpPr>
+          <p:nvPr>
+            <p:ph type="sldNum" idx="5" sz="quarter"/>
+          </p:nvPr>
+        </p:nvSpPr>
+        <p:spPr/>
+      </p:sp>
+    </p:spTree>
+  </p:cSld>
+  <p:clrMapOvr>
+    <a:masterClrMapping/>
+  </p:clrMapOvr>
+</p:notes>
+</file>
+
+<file path=ppt/notesSlides/notesSlide3.xml><?xml version="1.0" encoding="utf-8"?>
+<p:notes xmlns:a="http://schemas.openxmlformats.org/drawingml/2006/main" xmlns:p="http://schemas.openxmlformats.org/presentationml/2006/main" xmlns:r="http://schemas.openxmlformats.org/officeDocument/2006/relationships">
+  <p:cSld>
+    <p:spTree>
+      <p:nvGrpSpPr>
+        <p:cNvPr id="1" name=""/>
+        <p:cNvGrpSpPr/>
+        <p:nvPr/>
+      </p:nvGrpSpPr>
+      <p:grpSpPr>
+        <a:xfrm>
+          <a:off x="0" y="0"/>
+          <a:ext cx="0" cy="0"/>
+          <a:chOff x="0" y="0"/>
+          <a:chExt cx="0" cy="0"/>
+        </a:xfrm>
+      </p:grpSpPr>
+      <p:sp>
+        <p:nvSpPr>
+          <p:cNvPr id="2" name="Slide Image Placeholder 1"/>
+          <p:cNvSpPr>
+            <a:spLocks noGrp="1"/>
+          </p:cNvSpPr>
+          <p:nvPr>
+            <p:ph type="sldImg" idx="2"/>
+          </p:nvPr>
+        </p:nvSpPr>
+        <p:spPr/>
+      </p:sp>
+      <p:sp>
+        <p:nvSpPr>
+          <p:cNvPr id="3" name="Notes Placeholder 2"/>
+          <p:cNvSpPr>
+            <a:spLocks noGrp="1"/>
+          </p:cNvSpPr>
+          <p:nvPr>
+            <p:ph type="body" idx="3" sz="quarter"/>
+          </p:nvPr>
+        </p:nvSpPr>
+        <p:spPr/>
+        <p:txBody>
+          <a:bodyPr/>
+          <a:lstStyle/>
+          <a:p>
+            <a:r>
+              <a:t>Alexander · 15 s</a:t>
+            </a:r>
+          </a:p>
+          <a:p>
+            <a:r>
+              <a:t>Todo empieza antes de que el cliente llame: el sistema revisa inventario y consumo, y avisa qué punto entra en riesgo y cuánto reponer.</a:t>
+            </a:r>
+          </a:p>
+        </p:txBody>
+      </p:sp>
+      <p:sp>
+        <p:nvSpPr>
+          <p:cNvPr id="4" name="Slide Number Placeholder 3"/>
+          <p:cNvSpPr>
+            <a:spLocks noGrp="1"/>
+          </p:cNvSpPr>
+          <p:nvPr>
+            <p:ph type="sldNum" idx="5" sz="quarter"/>
+          </p:nvPr>
+        </p:nvSpPr>
+        <p:spPr/>
+      </p:sp>
+    </p:spTree>
+  </p:cSld>
+  <p:clrMapOvr>
+    <a:masterClrMapping/>
+  </p:clrMapOvr>
+</p:notes>
+</file>
+
+<file path=ppt/notesSlides/notesSlide4.xml><?xml version="1.0" encoding="utf-8"?>
+<p:notes xmlns:a="http://schemas.openxmlformats.org/drawingml/2006/main" xmlns:p="http://schemas.openxmlformats.org/presentationml/2006/main" xmlns:r="http://schemas.openxmlformats.org/officeDocument/2006/relationships">
+  <p:cSld>
+    <p:spTree>
+      <p:nvGrpSpPr>
+        <p:cNvPr id="1" name=""/>
+        <p:cNvGrpSpPr/>
+        <p:nvPr/>
+      </p:nvGrpSpPr>
+      <p:grpSpPr>
+        <a:xfrm>
+          <a:off x="0" y="0"/>
+          <a:ext cx="0" cy="0"/>
+          <a:chOff x="0" y="0"/>
+          <a:chExt cx="0" cy="0"/>
+        </a:xfrm>
+      </p:grpSpPr>
+      <p:sp>
+        <p:nvSpPr>
+          <p:cNvPr id="2" name="Slide Image Placeholder 1"/>
+          <p:cNvSpPr>
+            <a:spLocks noGrp="1"/>
+          </p:cNvSpPr>
+          <p:nvPr>
+            <p:ph type="sldImg" idx="2"/>
+          </p:nvPr>
+        </p:nvSpPr>
+        <p:spPr/>
+      </p:sp>
+      <p:sp>
+        <p:nvSpPr>
+          <p:cNvPr id="3" name="Notes Placeholder 2"/>
+          <p:cNvSpPr>
+            <a:spLocks noGrp="1"/>
+          </p:cNvSpPr>
+          <p:nvPr>
+            <p:ph type="body" idx="3" sz="quarter"/>
+          </p:nvPr>
+        </p:nvSpPr>
+        <p:spPr/>
+        <p:txBody>
+          <a:bodyPr/>
+          <a:lstStyle/>
+          <a:p>
+            <a:r>
+              <a:t>Alexander · 55 s</a:t>
+            </a:r>
+          </a:p>
+          <a:p>
+            <a:r>
+              <a:t>Y esta es la decisión, con costo completo y no solo kilómetros. A es la más barata: 57,89 dólares. Pero solo llega a tiempo a 5 de las 6 entregas críticas. B y C llegan al 100 %. Entre ellas, C, el operador contratado, cuesta 66,90 contra 69,89 de B. El motor recomienda C, con 90,8 puntos, y la inteligencia artificial le explica al planificador por qué, en palabras simples. La más barata no fue la mejor. Y la persona decide.</a:t>
+            </a:r>
+          </a:p>
+        </p:txBody>
+      </p:sp>
+      <p:sp>
+        <p:nvSpPr>
+          <p:cNvPr id="4" name="Slide Number Placeholder 3"/>
+          <p:cNvSpPr>
+            <a:spLocks noGrp="1"/>
+          </p:cNvSpPr>
+          <p:nvPr>
+            <p:ph type="sldNum" idx="5" sz="quarter"/>
+          </p:nvPr>
+        </p:nvSpPr>
+        <p:spPr/>
+      </p:sp>
+    </p:spTree>
+  </p:cSld>
+  <p:clrMapOvr>
+    <a:masterClrMapping/>
+  </p:clrMapOvr>
+</p:notes>
+</file>
+
+<file path=ppt/notesSlides/notesSlide5.xml><?xml version="1.0" encoding="utf-8"?>
+<p:notes xmlns:a="http://schemas.openxmlformats.org/drawingml/2006/main" xmlns:p="http://schemas.openxmlformats.org/presentationml/2006/main" xmlns:r="http://schemas.openxmlformats.org/officeDocument/2006/relationships">
+  <p:cSld>
+    <p:spTree>
+      <p:nvGrpSpPr>
+        <p:cNvPr id="1" name=""/>
+        <p:cNvGrpSpPr/>
+        <p:nvPr/>
+      </p:nvGrpSpPr>
+      <p:grpSpPr>
+        <a:xfrm>
+          <a:off x="0" y="0"/>
+          <a:ext cx="0" cy="0"/>
+          <a:chOff x="0" y="0"/>
+          <a:chExt cx="0" cy="0"/>
+        </a:xfrm>
+      </p:grpSpPr>
+      <p:sp>
+        <p:nvSpPr>
+          <p:cNvPr id="2" name="Slide Image Placeholder 1"/>
+          <p:cNvSpPr>
+            <a:spLocks noGrp="1"/>
+          </p:cNvSpPr>
+          <p:nvPr>
+            <p:ph type="sldImg" idx="2"/>
+          </p:nvPr>
+        </p:nvSpPr>
+        <p:spPr/>
+      </p:sp>
+      <p:sp>
+        <p:nvSpPr>
+          <p:cNvPr id="3" name="Notes Placeholder 2"/>
+          <p:cNvSpPr>
+            <a:spLocks noGrp="1"/>
+          </p:cNvSpPr>
+          <p:nvPr>
+            <p:ph type="body" idx="3" sz="quarter"/>
+          </p:nvPr>
+        </p:nvSpPr>
+        <p:spPr/>
+        <p:txBody>
+          <a:bodyPr/>
+          <a:lstStyle/>
+          <a:p>
+            <a:r>
+              <a:t>Alexander · 30 s</a:t>
+            </a:r>
+          </a:p>
+          <a:p>
+            <a:r>
+              <a:t>Elegida la opción, el sistema arma la ruta con capacidad, horarios y jornada, y el planificador la aprueba. En el camino queda registro: cada caja viaja con QR y los daños o errores de rotulado se anotan con su motivo. Así, cuando alguien pregunta qué se entregó, hay respuesta.</a:t>
+            </a:r>
+          </a:p>
+        </p:txBody>
+      </p:sp>
+      <p:sp>
+        <p:nvSpPr>
+          <p:cNvPr id="4" name="Slide Number Placeholder 3"/>
+          <p:cNvSpPr>
+            <a:spLocks noGrp="1"/>
+          </p:cNvSpPr>
+          <p:nvPr>
+            <p:ph type="sldNum" idx="5" sz="quarter"/>
+          </p:nvPr>
+        </p:nvSpPr>
+        <p:spPr/>
+      </p:sp>
+    </p:spTree>
+  </p:cSld>
+  <p:clrMapOvr>
+    <a:masterClrMapping/>
+  </p:clrMapOvr>
+</p:notes>
+</file>
+
+<file path=ppt/notesSlides/notesSlide6.xml><?xml version="1.0" encoding="utf-8"?>
+<p:notes xmlns:a="http://schemas.openxmlformats.org/drawingml/2006/main" xmlns:p="http://schemas.openxmlformats.org/presentationml/2006/main" xmlns:r="http://schemas.openxmlformats.org/officeDocument/2006/relationships">
+  <p:cSld>
+    <p:spTree>
+      <p:nvGrpSpPr>
+        <p:cNvPr id="1" name=""/>
+        <p:cNvGrpSpPr/>
+        <p:nvPr/>
+      </p:nvGrpSpPr>
+      <p:grpSpPr>
+        <a:xfrm>
+          <a:off x="0" y="0"/>
+          <a:ext cx="0" cy="0"/>
+          <a:chOff x="0" y="0"/>
+          <a:chExt cx="0" cy="0"/>
+        </a:xfrm>
+      </p:grpSpPr>
+      <p:sp>
+        <p:nvSpPr>
+          <p:cNvPr id="2" name="Slide Image Placeholder 1"/>
+          <p:cNvSpPr>
+            <a:spLocks noGrp="1"/>
+          </p:cNvSpPr>
+          <p:nvPr>
+            <p:ph type="sldImg" idx="2"/>
+          </p:nvPr>
+        </p:nvSpPr>
+        <p:spPr/>
+      </p:sp>
+      <p:sp>
+        <p:nvSpPr>
+          <p:cNvPr id="3" name="Notes Placeholder 2"/>
+          <p:cNvSpPr>
+            <a:spLocks noGrp="1"/>
+          </p:cNvSpPr>
+          <p:nvPr>
+            <p:ph type="body" idx="3" sz="quarter"/>
+          </p:nvPr>
+        </p:nvSpPr>
+        <p:spPr/>
+        <p:txBody>
+          <a:bodyPr/>
+          <a:lstStyle/>
+          <a:p>
+            <a:r>
+              <a:t>Bryan · 35 s</a:t>
+            </a:r>
+          </a:p>
+          <a:p>
+            <a:r>
+              <a:t>¿Qué cambia? Lo que escuchamos en el sector es que se repone por calendario o por urgencia, y la entrega se decide por kilómetros. Nosotros hacemos con la entrega lo que se hace con una buena cotización: ponerle el costo completo antes de decidir. Un motor de reglas calcula, siempre igual con los mismos datos. La inteligencia artificial explica, no inventa cifras, y si falla hay una explicación de respaldo. La alerta no se queda en alerta: termina en una decisión con costo y en una entrega comprobable.</a:t>
+            </a:r>
+          </a:p>
+        </p:txBody>
+      </p:sp>
+      <p:sp>
+        <p:nvSpPr>
+          <p:cNvPr id="4" name="Slide Number Placeholder 3"/>
+          <p:cNvSpPr>
+            <a:spLocks noGrp="1"/>
+          </p:cNvSpPr>
+          <p:nvPr>
+            <p:ph type="sldNum" idx="5" sz="quarter"/>
+          </p:nvPr>
+        </p:nvSpPr>
+        <p:spPr/>
+      </p:sp>
+    </p:spTree>
+  </p:cSld>
+  <p:clrMapOvr>
+    <a:masterClrMapping/>
+  </p:clrMapOvr>
+</p:notes>
+</file>
+
+<file path=ppt/notesSlides/notesSlide7.xml><?xml version="1.0" encoding="utf-8"?>
+<p:notes xmlns:a="http://schemas.openxmlformats.org/drawingml/2006/main" xmlns:p="http://schemas.openxmlformats.org/presentationml/2006/main" xmlns:r="http://schemas.openxmlformats.org/officeDocument/2006/relationships">
+  <p:cSld>
+    <p:spTree>
+      <p:nvGrpSpPr>
+        <p:cNvPr id="1" name=""/>
+        <p:cNvGrpSpPr/>
+        <p:nvPr/>
+      </p:nvGrpSpPr>
+      <p:grpSpPr>
+        <a:xfrm>
+          <a:off x="0" y="0"/>
+          <a:ext cx="0" cy="0"/>
+          <a:chOff x="0" y="0"/>
+          <a:chExt cx="0" cy="0"/>
+        </a:xfrm>
+      </p:grpSpPr>
+      <p:sp>
+        <p:nvSpPr>
+          <p:cNvPr id="2" name="Slide Image Placeholder 1"/>
+          <p:cNvSpPr>
+            <a:spLocks noGrp="1"/>
+          </p:cNvSpPr>
+          <p:nvPr>
+            <p:ph type="sldImg" idx="2"/>
+          </p:nvPr>
+        </p:nvSpPr>
+        <p:spPr/>
+      </p:sp>
+      <p:sp>
+        <p:nvSpPr>
+          <p:cNvPr id="3" name="Notes Placeholder 2"/>
+          <p:cNvSpPr>
+            <a:spLocks noGrp="1"/>
+          </p:cNvSpPr>
+          <p:nvPr>
+            <p:ph type="body" idx="3" sz="quarter"/>
+          </p:nvPr>
+        </p:nvSpPr>
+        <p:spPr/>
+        <p:txBody>
+          <a:bodyPr/>
+          <a:lstStyle/>
+          <a:p>
+            <a:r>
+              <a:t>Anthony · 25 s</a:t>
+            </a:r>
+          </a:p>
+          <a:p>
+            <a:r>
+              <a:t>Construido: de la alerta a la prueba de entrega. Ensayado: la decisión A, B y C en un ensayo técnico sobre un escenario sintético de Quito de 40 puntos, y una corrida del agente de inteligencia artificial, incluida su caída al respaldo. Siguiente fase: usarlo en una empresa real, cargar sus datos y medir contra su línea base, probar el recorrido sin señal en un teléfono real, y llevar la comparación A, B y C a producción.</a:t>
+            </a:r>
+          </a:p>
+        </p:txBody>
+      </p:sp>
+      <p:sp>
+        <p:nvSpPr>
+          <p:cNvPr id="4" name="Slide Number Placeholder 3"/>
+          <p:cNvSpPr>
+            <a:spLocks noGrp="1"/>
+          </p:cNvSpPr>
+          <p:nvPr>
+            <p:ph type="sldNum" idx="5" sz="quarter"/>
+          </p:nvPr>
+        </p:nvSpPr>
+        <p:spPr/>
+      </p:sp>
+    </p:spTree>
+  </p:cSld>
+  <p:clrMapOvr>
+    <a:masterClrMapping/>
+  </p:clrMapOvr>
+</p:notes>
+</file>
+
+<file path=ppt/notesSlides/notesSlide8.xml><?xml version="1.0" encoding="utf-8"?>
+<p:notes xmlns:a="http://schemas.openxmlformats.org/drawingml/2006/main" xmlns:p="http://schemas.openxmlformats.org/presentationml/2006/main" xmlns:r="http://schemas.openxmlformats.org/officeDocument/2006/relationships">
+  <p:cSld>
+    <p:spTree>
+      <p:nvGrpSpPr>
+        <p:cNvPr id="1" name=""/>
+        <p:cNvGrpSpPr/>
+        <p:nvPr/>
+      </p:nvGrpSpPr>
+      <p:grpSpPr>
+        <a:xfrm>
+          <a:off x="0" y="0"/>
+          <a:ext cx="0" cy="0"/>
+          <a:chOff x="0" y="0"/>
+          <a:chExt cx="0" cy="0"/>
+        </a:xfrm>
+      </p:grpSpPr>
+      <p:sp>
+        <p:nvSpPr>
+          <p:cNvPr id="2" name="Slide Image Placeholder 1"/>
+          <p:cNvSpPr>
+            <a:spLocks noGrp="1"/>
+          </p:cNvSpPr>
+          <p:nvPr>
+            <p:ph type="sldImg" idx="2"/>
+          </p:nvPr>
+        </p:nvSpPr>
+        <p:spPr/>
+      </p:sp>
+      <p:sp>
+        <p:nvSpPr>
+          <p:cNvPr id="3" name="Notes Placeholder 2"/>
+          <p:cNvSpPr>
+            <a:spLocks noGrp="1"/>
+          </p:cNvSpPr>
+          <p:nvPr>
+            <p:ph type="body" idx="3" sz="quarter"/>
+          </p:nvPr>
+        </p:nvSpPr>
+        <p:spPr/>
+        <p:txBody>
+          <a:bodyPr/>
+          <a:lstStyle/>
+          <a:p>
+            <a:r>
+              <a:t>Jorge · 40 s</a:t>
+            </a:r>
+          </a:p>
+          <a:p>
+            <a:r>
+              <a:t>En un piloto queremos medir tres cosas: menos faltantes descubiertos tarde, más entregas críticas a tiempo y cuánto cuesta realmente cada entrega. No prometemos un ahorro: lo medimos contra una línea base. No necesita hardware nuevo: funciona en la web y en el teléfono del conductor. Proponemos implementación inicial más suscripción, que validaremos. Y si falta un dato, el sistema dice “sin dato”. Esos indicadores alimentan informes ejecutivos: ya tenemos la sección Reportes.</a:t>
+            </a:r>
+          </a:p>
+        </p:txBody>
+      </p:sp>
+      <p:sp>
+        <p:nvSpPr>
+          <p:cNvPr id="4" name="Slide Number Placeholder 3"/>
+          <p:cNvSpPr>
+            <a:spLocks noGrp="1"/>
+          </p:cNvSpPr>
+          <p:nvPr>
+            <p:ph type="sldNum" idx="5" sz="quarter"/>
+          </p:nvPr>
+        </p:nvSpPr>
+        <p:spPr/>
+      </p:sp>
+    </p:spTree>
+  </p:cSld>
+  <p:clrMapOvr>
+    <a:masterClrMapping/>
+  </p:clrMapOvr>
+</p:notes>
+</file>
+
+<file path=ppt/notesSlides/notesSlide9.xml><?xml version="1.0" encoding="utf-8"?>
+<p:notes xmlns:a="http://schemas.openxmlformats.org/drawingml/2006/main" xmlns:p="http://schemas.openxmlformats.org/presentationml/2006/main" xmlns:r="http://schemas.openxmlformats.org/officeDocument/2006/relationships">
+  <p:cSld>
+    <p:spTree>
+      <p:nvGrpSpPr>
+        <p:cNvPr id="1" name=""/>
+        <p:cNvGrpSpPr/>
+        <p:nvPr/>
+      </p:nvGrpSpPr>
+      <p:grpSpPr>
+        <a:xfrm>
+          <a:off x="0" y="0"/>
+          <a:ext cx="0" cy="0"/>
+          <a:chOff x="0" y="0"/>
+          <a:chExt cx="0" cy="0"/>
+        </a:xfrm>
+      </p:grpSpPr>
+      <p:sp>
+        <p:nvSpPr>
+          <p:cNvPr id="2" name="Slide Image Placeholder 1"/>
+          <p:cNvSpPr>
+            <a:spLocks noGrp="1"/>
+          </p:cNvSpPr>
+          <p:nvPr>
+            <p:ph type="sldImg" idx="2"/>
+          </p:nvPr>
+        </p:nvSpPr>
+        <p:spPr/>
+      </p:sp>
+      <p:sp>
+        <p:nvSpPr>
+          <p:cNvPr id="3" name="Notes Placeholder 2"/>
+          <p:cNvSpPr>
+            <a:spLocks noGrp="1"/>
+          </p:cNvSpPr>
+          <p:nvPr>
+            <p:ph type="body" idx="3" sz="quarter"/>
+          </p:nvPr>
+        </p:nvSpPr>
+        <p:spPr/>
+        <p:txBody>
+          <a:bodyPr/>
+          <a:lstStyle/>
+          <a:p>
+            <a:r>
+              <a:t>Joseph · 15 s</a:t>
+            </a:r>
+          </a:p>
+          <a:p>
+            <a:r>
+              <a:t>Una buena cotización de limpieza suma el costo completo. Nosotros hacemos lo mismo con la entrega: la decidimos con su costo real, antes de hacerla, y dejamos la prueba. Buscamos una empresa de limpieza para un piloto: con su línea base, indicadores acordados y sus datos. Gracias.</a:t>
+            </a:r>
+          </a:p>
+        </p:txBody>
+      </p:sp>
+      <p:sp>
+        <p:nvSpPr>
+          <p:cNvPr id="4" name="Slide Number Placeholder 3"/>
+          <p:cNvSpPr>
+            <a:spLocks noGrp="1"/>
+          </p:cNvSpPr>
+          <p:nvPr>
+            <p:ph type="sldNum" idx="5" sz="quarter"/>
+          </p:nvPr>
+        </p:nvSpPr>
+        <p:spPr/>
+      </p:sp>
+    </p:spTree>
+  </p:cSld>
+  <p:clrMapOvr>
+    <a:masterClrMapping/>
+  </p:clrMapOvr>
+</p:notes>
 </file>
 
 <file path=ppt/slideLayouts/slideLayout1.xml><?xml version="1.0" encoding="utf-8"?>
@@ -3880,6 +4981,1035 @@
       <p:bldP spid="13" grpId="0" animBg="1"/>
     </p:bldLst>
   </p:timing>
+</p:sld>
+</file>
+
+<file path=ppt/slides/slide10.xml><?xml version="1.0" encoding="utf-8"?>
+<p:sld xmlns:a="http://schemas.openxmlformats.org/drawingml/2006/main" xmlns:p="http://schemas.openxmlformats.org/presentationml/2006/main" xmlns:r="http://schemas.openxmlformats.org/officeDocument/2006/relationships">
+  <p:cSld>
+    <p:bg>
+      <p:bgPr>
+        <a:solidFill>
+          <a:srgbClr val="162451"/>
+        </a:solidFill>
+        <a:effectLst/>
+      </p:bgPr>
+    </p:bg>
+    <p:spTree>
+      <p:nvGrpSpPr>
+        <p:cNvPr id="1" name=""/>
+        <p:cNvGrpSpPr/>
+        <p:nvPr/>
+      </p:nvGrpSpPr>
+      <p:grpSpPr/>
+      <p:sp>
+        <p:nvSpPr>
+          <p:cNvPr id="2" name="TextBox 1"/>
+          <p:cNvSpPr txBox="1"/>
+          <p:nvPr/>
+        </p:nvSpPr>
+        <p:spPr>
+          <a:xfrm>
+            <a:off x="6385255" y="411480"/>
+            <a:ext cx="5120640" cy="274320"/>
+          </a:xfrm>
+          <a:prstGeom prst="rect">
+            <a:avLst/>
+          </a:prstGeom>
+          <a:noFill/>
+        </p:spPr>
+        <p:txBody>
+          <a:bodyPr wrap="square" anchor="t" lIns="0" rIns="0" tIns="0" bIns="0">
+            <a:spAutoFit/>
+          </a:bodyPr>
+          <a:lstStyle/>
+          <a:p>
+            <a:pPr algn="r">
+              <a:spcAft>
+                <a:spcPts val="0"/>
+              </a:spcAft>
+            </a:pPr>
+            <a:r>
+              <a:rPr sz="1100" b="0" i="0" spc="100">
+                <a:solidFill>
+                  <a:srgbClr val="B9C2DC"/>
+                </a:solidFill>
+                <a:latin typeface="Open Sans"/>
+              </a:rPr>
+              <a:t>HACKATHON EXPO CLEAN 2026 · RETO 1 · 10</a:t>
+            </a:r>
+          </a:p>
+        </p:txBody>
+      </p:sp>
+      <p:grpSp>
+        <p:nvGrpSpPr>
+          <p:cNvPr id="3" name="Group 2"/>
+          <p:cNvGrpSpPr/>
+          <p:nvPr/>
+        </p:nvGrpSpPr>
+        <p:grpSpPr>
+          <a:xfrm>
+            <a:off x="685800" y="402336"/>
+            <a:ext cx="10820095" cy="1060704"/>
+            <a:chOff x="685800" y="402336"/>
+            <a:chExt cx="10820095" cy="1060704"/>
+          </a:xfrm>
+        </p:grpSpPr>
+        <p:sp>
+          <p:nvSpPr>
+            <p:cNvPr id="4" name="Rectangle 3"/>
+            <p:cNvSpPr/>
+            <p:nvPr/>
+          </p:nvSpPr>
+          <p:spPr>
+            <a:xfrm>
+              <a:off x="685800" y="402336"/>
+              <a:ext cx="45720" cy="274320"/>
+            </a:xfrm>
+            <a:prstGeom prst="rect">
+              <a:avLst/>
+            </a:prstGeom>
+            <a:solidFill>
+              <a:srgbClr val="C4A857"/>
+            </a:solidFill>
+            <a:ln>
+              <a:noFill/>
+            </a:ln>
+          </p:spPr>
+          <p:txBody>
+            <a:bodyPr rtlCol="0" anchor="ctr"/>
+            <a:lstStyle/>
+            <a:p>
+              <a:pPr algn="ctr"/>
+            </a:p>
+          </p:txBody>
+        </p:sp>
+        <p:sp>
+          <p:nvSpPr>
+            <p:cNvPr id="5" name="TextBox 4"/>
+            <p:cNvSpPr txBox="1"/>
+            <p:nvPr/>
+          </p:nvSpPr>
+          <p:spPr>
+            <a:xfrm>
+              <a:off x="841248" y="411480"/>
+              <a:ext cx="5852160" cy="274320"/>
+            </a:xfrm>
+            <a:prstGeom prst="rect">
+              <a:avLst/>
+            </a:prstGeom>
+            <a:noFill/>
+          </p:spPr>
+          <p:txBody>
+            <a:bodyPr wrap="square" anchor="t" lIns="0" rIns="0" tIns="0" bIns="0">
+              <a:spAutoFit/>
+            </a:bodyPr>
+            <a:lstStyle/>
+            <a:p>
+              <a:pPr algn="l">
+                <a:spcAft>
+                  <a:spcPts val="0"/>
+                </a:spcAft>
+              </a:pPr>
+              <a:r>
+                <a:rPr sz="1300" b="1" i="0" spc="200">
+                  <a:solidFill>
+                    <a:srgbClr val="C4A857"/>
+                  </a:solidFill>
+                  <a:latin typeface="Open Sans"/>
+                </a:rPr>
+                <a:t>ACCESO PARA EL JURADO</a:t>
+              </a:r>
+            </a:p>
+          </p:txBody>
+        </p:sp>
+        <p:sp>
+          <p:nvSpPr>
+            <p:cNvPr id="6" name="TextBox 5"/>
+            <p:cNvSpPr txBox="1"/>
+            <p:nvPr/>
+          </p:nvSpPr>
+          <p:spPr>
+            <a:xfrm>
+              <a:off x="685800" y="731520"/>
+              <a:ext cx="10820095" cy="731520"/>
+            </a:xfrm>
+            <a:prstGeom prst="rect">
+              <a:avLst/>
+            </a:prstGeom>
+            <a:noFill/>
+          </p:spPr>
+          <p:txBody>
+            <a:bodyPr wrap="square" anchor="t" lIns="0" rIns="0" tIns="0" bIns="0">
+              <a:spAutoFit/>
+            </a:bodyPr>
+            <a:lstStyle/>
+            <a:p>
+              <a:pPr algn="l">
+                <a:spcAft>
+                  <a:spcPts val="0"/>
+                </a:spcAft>
+              </a:pPr>
+              <a:r>
+                <a:rPr sz="3600" b="1" i="0">
+                  <a:solidFill>
+                    <a:srgbClr val="FFFFFF"/>
+                  </a:solidFill>
+                  <a:latin typeface="Oswald"/>
+                </a:rPr>
+                <a:t>Pruébenlo ustedes</a:t>
+              </a:r>
+            </a:p>
+          </p:txBody>
+        </p:sp>
+      </p:grpSp>
+      <p:sp>
+        <p:nvSpPr>
+          <p:cNvPr id="7" name="Rectangle 6"/>
+          <p:cNvSpPr/>
+          <p:nvPr/>
+        </p:nvSpPr>
+        <p:spPr>
+          <a:xfrm>
+            <a:off x="685800" y="6217920"/>
+            <a:ext cx="10820095" cy="10972"/>
+          </a:xfrm>
+          <a:prstGeom prst="rect">
+            <a:avLst/>
+          </a:prstGeom>
+          <a:solidFill>
+            <a:srgbClr val="2E3B6E"/>
+          </a:solidFill>
+          <a:ln>
+            <a:noFill/>
+          </a:ln>
+        </p:spPr>
+        <p:txBody>
+          <a:bodyPr rtlCol="0" anchor="ctr"/>
+          <a:lstStyle/>
+          <a:p>
+            <a:pPr algn="ctr"/>
+          </a:p>
+        </p:txBody>
+      </p:sp>
+      <p:pic>
+        <p:nvPicPr>
+          <p:cNvPr id="8" name="Picture 7" descr="istpet-logo-blanco.png"/>
+          <p:cNvPicPr>
+            <a:picLocks noChangeAspect="1"/>
+          </p:cNvPicPr>
+          <p:nvPr/>
+        </p:nvPicPr>
+        <p:blipFill>
+          <a:blip r:embed="rId2"/>
+          <a:stretch>
+            <a:fillRect/>
+          </a:stretch>
+        </p:blipFill>
+        <p:spPr>
+          <a:xfrm>
+            <a:off x="685800" y="6373368"/>
+            <a:ext cx="872345" cy="310896"/>
+          </a:xfrm>
+          <a:prstGeom prst="rect">
+            <a:avLst/>
+          </a:prstGeom>
+        </p:spPr>
+      </p:pic>
+      <p:sp>
+        <p:nvSpPr>
+          <p:cNvPr id="9" name="Rectangle 8"/>
+          <p:cNvSpPr/>
+          <p:nvPr/>
+        </p:nvSpPr>
+        <p:spPr>
+          <a:xfrm>
+            <a:off x="1704448" y="6355080"/>
+            <a:ext cx="22860" cy="347472"/>
+          </a:xfrm>
+          <a:prstGeom prst="rect">
+            <a:avLst/>
+          </a:prstGeom>
+          <a:solidFill>
+            <a:srgbClr val="C4A857"/>
+          </a:solidFill>
+          <a:ln>
+            <a:noFill/>
+          </a:ln>
+        </p:spPr>
+        <p:txBody>
+          <a:bodyPr rtlCol="0" anchor="ctr"/>
+          <a:lstStyle/>
+          <a:p>
+            <a:pPr algn="ctr"/>
+          </a:p>
+        </p:txBody>
+      </p:sp>
+      <p:sp>
+        <p:nvSpPr>
+          <p:cNvPr id="10" name="TextBox 9"/>
+          <p:cNvSpPr txBox="1"/>
+          <p:nvPr/>
+        </p:nvSpPr>
+        <p:spPr>
+          <a:xfrm>
+            <a:off x="1859897" y="6327648"/>
+            <a:ext cx="9645998" cy="475488"/>
+          </a:xfrm>
+          <a:prstGeom prst="rect">
+            <a:avLst/>
+          </a:prstGeom>
+          <a:noFill/>
+        </p:spPr>
+        <p:txBody>
+          <a:bodyPr wrap="square" anchor="t" lIns="0" rIns="0" tIns="0" bIns="0">
+            <a:spAutoFit/>
+          </a:bodyPr>
+          <a:lstStyle/>
+          <a:p>
+            <a:pPr algn="l">
+              <a:spcAft>
+                <a:spcPts val="0"/>
+              </a:spcAft>
+            </a:pPr>
+            <a:r>
+              <a:rPr sz="1000" b="0" i="0">
+                <a:solidFill>
+                  <a:srgbClr val="B9C2DC"/>
+                </a:solidFill>
+                <a:latin typeface="Open Sans"/>
+              </a:rPr>
+              <a:t>Cuenta del jurado · Auditor · Solo lectura · Datos sintéticos</a:t>
+            </a:r>
+          </a:p>
+        </p:txBody>
+      </p:sp>
+      <p:pic>
+        <p:nvPicPr>
+          <p:cNvPr id="11" name="Picture 10" descr="qr.png">
+            <a:hlinkClick r:id="rId4"/>
+          </p:cNvPr>
+          <p:cNvPicPr>
+            <a:picLocks noChangeAspect="1"/>
+          </p:cNvPicPr>
+          <p:nvPr/>
+        </p:nvPicPr>
+        <p:blipFill>
+          <a:blip r:embed="rId3"/>
+          <a:stretch>
+            <a:fillRect/>
+          </a:stretch>
+        </p:blipFill>
+        <p:spPr>
+          <a:xfrm>
+            <a:off x="685800" y="1737360"/>
+            <a:ext cx="3794760" cy="3794760"/>
+          </a:xfrm>
+          <a:prstGeom prst="rect">
+            <a:avLst/>
+          </a:prstGeom>
+        </p:spPr>
+      </p:pic>
+      <p:sp>
+        <p:nvSpPr>
+          <p:cNvPr id="12" name="TextBox 11"/>
+          <p:cNvSpPr txBox="1"/>
+          <p:nvPr/>
+        </p:nvSpPr>
+        <p:spPr>
+          <a:xfrm>
+            <a:off x="685800" y="5605272"/>
+            <a:ext cx="4023360" cy="365760"/>
+          </a:xfrm>
+          <a:prstGeom prst="rect">
+            <a:avLst/>
+          </a:prstGeom>
+          <a:noFill/>
+        </p:spPr>
+        <p:txBody>
+          <a:bodyPr wrap="square" anchor="t" lIns="0" rIns="0" tIns="0" bIns="0">
+            <a:spAutoFit/>
+          </a:bodyPr>
+          <a:lstStyle/>
+          <a:p>
+            <a:pPr algn="ctr">
+              <a:spcAft>
+                <a:spcPts val="0"/>
+              </a:spcAft>
+            </a:pPr>
+            <a:r>
+              <a:rPr sz="2100" b="1" i="0">
+                <a:solidFill>
+                  <a:srgbClr val="E6D7A3"/>
+                </a:solidFill>
+                <a:latin typeface="Open Sans"/>
+              </a:rPr>
+              <a:t>istpetdev.doicela.dev</a:t>
+            </a:r>
+          </a:p>
+        </p:txBody>
+      </p:sp>
+      <p:sp>
+        <p:nvSpPr>
+          <p:cNvPr id="13" name="Rectangle 12"/>
+          <p:cNvSpPr/>
+          <p:nvPr/>
+        </p:nvSpPr>
+        <p:spPr>
+          <a:xfrm>
+            <a:off x="4937760" y="1737360"/>
+            <a:ext cx="6537960" cy="1508760"/>
+          </a:xfrm>
+          <a:prstGeom prst="rect">
+            <a:avLst/>
+          </a:prstGeom>
+          <a:solidFill>
+            <a:srgbClr val="2E3B6E"/>
+          </a:solidFill>
+          <a:ln>
+            <a:noFill/>
+          </a:ln>
+        </p:spPr>
+        <p:txBody>
+          <a:bodyPr rtlCol="0" anchor="ctr"/>
+          <a:lstStyle/>
+          <a:p>
+            <a:pPr algn="ctr"/>
+          </a:p>
+        </p:txBody>
+      </p:sp>
+      <p:sp>
+        <p:nvSpPr>
+          <p:cNvPr id="14" name="TextBox 13"/>
+          <p:cNvSpPr txBox="1"/>
+          <p:nvPr/>
+        </p:nvSpPr>
+        <p:spPr>
+          <a:xfrm>
+            <a:off x="5138928" y="1837943"/>
+            <a:ext cx="1143000" cy="219456"/>
+          </a:xfrm>
+          <a:prstGeom prst="rect">
+            <a:avLst/>
+          </a:prstGeom>
+          <a:noFill/>
+        </p:spPr>
+        <p:txBody>
+          <a:bodyPr wrap="square" anchor="t" lIns="0" rIns="0" tIns="0" bIns="0">
+            <a:spAutoFit/>
+          </a:bodyPr>
+          <a:lstStyle/>
+          <a:p>
+            <a:pPr algn="l">
+              <a:spcAft>
+                <a:spcPts val="0"/>
+              </a:spcAft>
+            </a:pPr>
+            <a:r>
+              <a:rPr sz="1100" b="1" i="0">
+                <a:solidFill>
+                  <a:srgbClr val="C4A857"/>
+                </a:solidFill>
+                <a:latin typeface="Open Sans"/>
+              </a:rPr>
+              <a:t>Usuario</a:t>
+            </a:r>
+          </a:p>
+        </p:txBody>
+      </p:sp>
+      <p:sp>
+        <p:nvSpPr>
+          <p:cNvPr id="15" name="TextBox 14"/>
+          <p:cNvSpPr txBox="1"/>
+          <p:nvPr/>
+        </p:nvSpPr>
+        <p:spPr>
+          <a:xfrm>
+            <a:off x="6355080" y="1792224"/>
+            <a:ext cx="4919472" cy="384048"/>
+          </a:xfrm>
+          <a:prstGeom prst="rect">
+            <a:avLst/>
+          </a:prstGeom>
+          <a:noFill/>
+        </p:spPr>
+        <p:txBody>
+          <a:bodyPr wrap="square" anchor="t" lIns="0" rIns="0" tIns="0" bIns="0">
+            <a:spAutoFit/>
+          </a:bodyPr>
+          <a:lstStyle/>
+          <a:p>
+            <a:pPr algn="l">
+              <a:spcAft>
+                <a:spcPts val="0"/>
+              </a:spcAft>
+            </a:pPr>
+            <a:r>
+              <a:rPr sz="2300" b="1" i="0">
+                <a:solidFill>
+                  <a:srgbClr val="FFFFFF"/>
+                </a:solidFill>
+                <a:latin typeface="Open Sans"/>
+              </a:rPr>
+              <a:t>jurado@expo.ec</a:t>
+            </a:r>
+          </a:p>
+        </p:txBody>
+      </p:sp>
+      <p:sp>
+        <p:nvSpPr>
+          <p:cNvPr id="16" name="TextBox 15"/>
+          <p:cNvSpPr txBox="1"/>
+          <p:nvPr/>
+        </p:nvSpPr>
+        <p:spPr>
+          <a:xfrm>
+            <a:off x="5138928" y="2331720"/>
+            <a:ext cx="1143000" cy="219456"/>
+          </a:xfrm>
+          <a:prstGeom prst="rect">
+            <a:avLst/>
+          </a:prstGeom>
+          <a:noFill/>
+        </p:spPr>
+        <p:txBody>
+          <a:bodyPr wrap="square" anchor="t" lIns="0" rIns="0" tIns="0" bIns="0">
+            <a:spAutoFit/>
+          </a:bodyPr>
+          <a:lstStyle/>
+          <a:p>
+            <a:pPr algn="l">
+              <a:spcAft>
+                <a:spcPts val="0"/>
+              </a:spcAft>
+            </a:pPr>
+            <a:r>
+              <a:rPr sz="1100" b="1" i="0">
+                <a:solidFill>
+                  <a:srgbClr val="C4A857"/>
+                </a:solidFill>
+                <a:latin typeface="Open Sans"/>
+              </a:rPr>
+              <a:t>Clave</a:t>
+            </a:r>
+          </a:p>
+        </p:txBody>
+      </p:sp>
+      <p:sp>
+        <p:nvSpPr>
+          <p:cNvPr id="17" name="TextBox 16"/>
+          <p:cNvSpPr txBox="1"/>
+          <p:nvPr/>
+        </p:nvSpPr>
+        <p:spPr>
+          <a:xfrm>
+            <a:off x="6355080" y="2286000"/>
+            <a:ext cx="4919472" cy="384048"/>
+          </a:xfrm>
+          <a:prstGeom prst="rect">
+            <a:avLst/>
+          </a:prstGeom>
+          <a:noFill/>
+        </p:spPr>
+        <p:txBody>
+          <a:bodyPr wrap="square" anchor="t" lIns="0" rIns="0" tIns="0" bIns="0">
+            <a:spAutoFit/>
+          </a:bodyPr>
+          <a:lstStyle/>
+          <a:p>
+            <a:pPr algn="l">
+              <a:spcAft>
+                <a:spcPts val="0"/>
+              </a:spcAft>
+            </a:pPr>
+            <a:r>
+              <a:rPr sz="2300" b="1" i="0">
+                <a:solidFill>
+                  <a:srgbClr val="FFFFFF"/>
+                </a:solidFill>
+                <a:latin typeface="Open Sans"/>
+              </a:rPr>
+              <a:t>Jurado.2026.ec</a:t>
+            </a:r>
+          </a:p>
+        </p:txBody>
+      </p:sp>
+      <p:sp>
+        <p:nvSpPr>
+          <p:cNvPr id="18" name="TextBox 17"/>
+          <p:cNvSpPr txBox="1"/>
+          <p:nvPr/>
+        </p:nvSpPr>
+        <p:spPr>
+          <a:xfrm>
+            <a:off x="5138928" y="2880360"/>
+            <a:ext cx="6135624" cy="228600"/>
+          </a:xfrm>
+          <a:prstGeom prst="rect">
+            <a:avLst/>
+          </a:prstGeom>
+          <a:noFill/>
+        </p:spPr>
+        <p:txBody>
+          <a:bodyPr wrap="square" anchor="t" lIns="0" rIns="0" tIns="0" bIns="0">
+            <a:spAutoFit/>
+          </a:bodyPr>
+          <a:lstStyle/>
+          <a:p>
+            <a:pPr algn="l">
+              <a:spcAft>
+                <a:spcPts val="0"/>
+              </a:spcAft>
+            </a:pPr>
+            <a:r>
+              <a:rPr sz="1200" b="0" i="0">
+                <a:solidFill>
+                  <a:srgbClr val="B9C2DC"/>
+                </a:solidFill>
+                <a:latin typeface="Open Sans"/>
+              </a:rPr>
+              <a:t>Botón: Torre de Control · Rol Auditor (solo lectura)</a:t>
+            </a:r>
+          </a:p>
+        </p:txBody>
+      </p:sp>
+      <p:sp>
+        <p:nvSpPr>
+          <p:cNvPr id="19" name="TextBox 18"/>
+          <p:cNvSpPr txBox="1"/>
+          <p:nvPr/>
+        </p:nvSpPr>
+        <p:spPr>
+          <a:xfrm>
+            <a:off x="4937760" y="3410712"/>
+            <a:ext cx="6537960" cy="320040"/>
+          </a:xfrm>
+          <a:prstGeom prst="rect">
+            <a:avLst/>
+          </a:prstGeom>
+          <a:noFill/>
+        </p:spPr>
+        <p:txBody>
+          <a:bodyPr wrap="square" anchor="t" lIns="0" rIns="0" tIns="0" bIns="0">
+            <a:spAutoFit/>
+          </a:bodyPr>
+          <a:lstStyle/>
+          <a:p>
+            <a:pPr algn="l">
+              <a:spcAft>
+                <a:spcPts val="0"/>
+              </a:spcAft>
+            </a:pPr>
+            <a:r>
+              <a:rPr sz="1600" b="1" i="0">
+                <a:solidFill>
+                  <a:srgbClr val="E6D7A3"/>
+                </a:solidFill>
+                <a:latin typeface="Open Sans"/>
+              </a:rPr>
+              <a:t>SEGURIDAD · AWS COGNITO (NUBE)</a:t>
+            </a:r>
+          </a:p>
+        </p:txBody>
+      </p:sp>
+      <p:sp>
+        <p:nvSpPr>
+          <p:cNvPr id="20" name="TextBox 19"/>
+          <p:cNvSpPr txBox="1"/>
+          <p:nvPr/>
+        </p:nvSpPr>
+        <p:spPr>
+          <a:xfrm>
+            <a:off x="4937760" y="3785615"/>
+            <a:ext cx="6537960" cy="219456"/>
+          </a:xfrm>
+          <a:prstGeom prst="rect">
+            <a:avLst/>
+          </a:prstGeom>
+          <a:noFill/>
+        </p:spPr>
+        <p:txBody>
+          <a:bodyPr wrap="square" anchor="t" lIns="0" rIns="0" tIns="0" bIns="0">
+            <a:spAutoFit/>
+          </a:bodyPr>
+          <a:lstStyle/>
+          <a:p>
+            <a:pPr algn="l">
+              <a:spcAft>
+                <a:spcPts val="0"/>
+              </a:spcAft>
+            </a:pPr>
+            <a:r>
+              <a:rPr sz="1260" b="0" i="0">
+                <a:solidFill>
+                  <a:srgbClr val="FFFFFF"/>
+                </a:solidFill>
+                <a:latin typeface="Open Sans"/>
+              </a:rPr>
+              <a:t>01  AWS Cognito valida el ingreso en la nube de Amazon.</a:t>
+            </a:r>
+          </a:p>
+        </p:txBody>
+      </p:sp>
+      <p:sp>
+        <p:nvSpPr>
+          <p:cNvPr id="21" name="TextBox 20"/>
+          <p:cNvSpPr txBox="1"/>
+          <p:nvPr/>
+        </p:nvSpPr>
+        <p:spPr>
+          <a:xfrm>
+            <a:off x="4937760" y="4000500"/>
+            <a:ext cx="6537960" cy="219456"/>
+          </a:xfrm>
+          <a:prstGeom prst="rect">
+            <a:avLst/>
+          </a:prstGeom>
+          <a:noFill/>
+        </p:spPr>
+        <p:txBody>
+          <a:bodyPr wrap="square" anchor="t" lIns="0" rIns="0" tIns="0" bIns="0">
+            <a:spAutoFit/>
+          </a:bodyPr>
+          <a:lstStyle/>
+          <a:p>
+            <a:pPr algn="l">
+              <a:spcAft>
+                <a:spcPts val="0"/>
+              </a:spcAft>
+            </a:pPr>
+            <a:r>
+              <a:rPr sz="1260" b="0" i="0">
+                <a:solidFill>
+                  <a:srgbClr val="FFFFFF"/>
+                </a:solidFill>
+                <a:latin typeface="Open Sans"/>
+              </a:rPr>
+              <a:t>02  Verifica usuario y clave antes de abrir el sistema.</a:t>
+            </a:r>
+          </a:p>
+        </p:txBody>
+      </p:sp>
+      <p:sp>
+        <p:nvSpPr>
+          <p:cNvPr id="22" name="TextBox 21"/>
+          <p:cNvSpPr txBox="1"/>
+          <p:nvPr/>
+        </p:nvSpPr>
+        <p:spPr>
+          <a:xfrm>
+            <a:off x="4937760" y="4215383"/>
+            <a:ext cx="6537960" cy="219456"/>
+          </a:xfrm>
+          <a:prstGeom prst="rect">
+            <a:avLst/>
+          </a:prstGeom>
+          <a:noFill/>
+        </p:spPr>
+        <p:txBody>
+          <a:bodyPr wrap="square" anchor="t" lIns="0" rIns="0" tIns="0" bIns="0">
+            <a:spAutoFit/>
+          </a:bodyPr>
+          <a:lstStyle/>
+          <a:p>
+            <a:pPr algn="l">
+              <a:spcAft>
+                <a:spcPts val="0"/>
+              </a:spcAft>
+            </a:pPr>
+            <a:r>
+              <a:rPr sz="1260" b="0" i="0">
+                <a:solidFill>
+                  <a:srgbClr val="FFFFFF"/>
+                </a:solidFill>
+                <a:latin typeface="Open Sans"/>
+              </a:rPr>
+              <a:t>03  La clave la protege Cognito, no nuestra base.</a:t>
+            </a:r>
+          </a:p>
+        </p:txBody>
+      </p:sp>
+      <p:sp>
+        <p:nvSpPr>
+          <p:cNvPr id="23" name="TextBox 22"/>
+          <p:cNvSpPr txBox="1"/>
+          <p:nvPr/>
+        </p:nvSpPr>
+        <p:spPr>
+          <a:xfrm>
+            <a:off x="4937760" y="4430268"/>
+            <a:ext cx="6537960" cy="219456"/>
+          </a:xfrm>
+          <a:prstGeom prst="rect">
+            <a:avLst/>
+          </a:prstGeom>
+          <a:noFill/>
+        </p:spPr>
+        <p:txBody>
+          <a:bodyPr wrap="square" anchor="t" lIns="0" rIns="0" tIns="0" bIns="0">
+            <a:spAutoFit/>
+          </a:bodyPr>
+          <a:lstStyle/>
+          <a:p>
+            <a:pPr algn="l">
+              <a:spcAft>
+                <a:spcPts val="0"/>
+              </a:spcAft>
+            </a:pPr>
+            <a:r>
+              <a:rPr sz="1260" b="0" i="0">
+                <a:solidFill>
+                  <a:srgbClr val="FFFFFF"/>
+                </a:solidFill>
+                <a:latin typeface="Open Sans"/>
+              </a:rPr>
+              <a:t>04  Al entrar entrega una sesión temporal.</a:t>
+            </a:r>
+          </a:p>
+        </p:txBody>
+      </p:sp>
+      <p:sp>
+        <p:nvSpPr>
+          <p:cNvPr id="24" name="TextBox 23"/>
+          <p:cNvSpPr txBox="1"/>
+          <p:nvPr/>
+        </p:nvSpPr>
+        <p:spPr>
+          <a:xfrm>
+            <a:off x="4937760" y="4645152"/>
+            <a:ext cx="6537960" cy="219456"/>
+          </a:xfrm>
+          <a:prstGeom prst="rect">
+            <a:avLst/>
+          </a:prstGeom>
+          <a:noFill/>
+        </p:spPr>
+        <p:txBody>
+          <a:bodyPr wrap="square" anchor="t" lIns="0" rIns="0" tIns="0" bIns="0">
+            <a:spAutoFit/>
+          </a:bodyPr>
+          <a:lstStyle/>
+          <a:p>
+            <a:pPr algn="l">
+              <a:spcAft>
+                <a:spcPts val="0"/>
+              </a:spcAft>
+            </a:pPr>
+            <a:r>
+              <a:rPr sz="1260" b="0" i="0">
+                <a:solidFill>
+                  <a:srgbClr val="FFFFFF"/>
+                </a:solidFill>
+                <a:latin typeface="Open Sans"/>
+              </a:rPr>
+              <a:t>05  La conexión viaja cifrada por HTTPS.</a:t>
+            </a:r>
+          </a:p>
+        </p:txBody>
+      </p:sp>
+      <p:sp>
+        <p:nvSpPr>
+          <p:cNvPr id="25" name="TextBox 24"/>
+          <p:cNvSpPr txBox="1"/>
+          <p:nvPr/>
+        </p:nvSpPr>
+        <p:spPr>
+          <a:xfrm>
+            <a:off x="4937760" y="4860036"/>
+            <a:ext cx="6537960" cy="219456"/>
+          </a:xfrm>
+          <a:prstGeom prst="rect">
+            <a:avLst/>
+          </a:prstGeom>
+          <a:noFill/>
+        </p:spPr>
+        <p:txBody>
+          <a:bodyPr wrap="square" anchor="t" lIns="0" rIns="0" tIns="0" bIns="0">
+            <a:spAutoFit/>
+          </a:bodyPr>
+          <a:lstStyle/>
+          <a:p>
+            <a:pPr algn="l">
+              <a:spcAft>
+                <a:spcPts val="0"/>
+              </a:spcAft>
+            </a:pPr>
+            <a:r>
+              <a:rPr sz="1260" b="0" i="0">
+                <a:solidFill>
+                  <a:srgbClr val="FFFFFF"/>
+                </a:solidFill>
+                <a:latin typeface="Open Sans"/>
+              </a:rPr>
+              <a:t>06  Cada cuenta tiene permisos según su rol.</a:t>
+            </a:r>
+          </a:p>
+        </p:txBody>
+      </p:sp>
+      <p:sp>
+        <p:nvSpPr>
+          <p:cNvPr id="26" name="TextBox 25"/>
+          <p:cNvSpPr txBox="1"/>
+          <p:nvPr/>
+        </p:nvSpPr>
+        <p:spPr>
+          <a:xfrm>
+            <a:off x="4937760" y="5074920"/>
+            <a:ext cx="6537960" cy="219456"/>
+          </a:xfrm>
+          <a:prstGeom prst="rect">
+            <a:avLst/>
+          </a:prstGeom>
+          <a:noFill/>
+        </p:spPr>
+        <p:txBody>
+          <a:bodyPr wrap="square" anchor="t" lIns="0" rIns="0" tIns="0" bIns="0">
+            <a:spAutoFit/>
+          </a:bodyPr>
+          <a:lstStyle/>
+          <a:p>
+            <a:pPr algn="l">
+              <a:spcAft>
+                <a:spcPts val="0"/>
+              </a:spcAft>
+            </a:pPr>
+            <a:r>
+              <a:rPr sz="1260" b="0" i="0">
+                <a:solidFill>
+                  <a:srgbClr val="FFFFFF"/>
+                </a:solidFill>
+                <a:latin typeface="Open Sans"/>
+              </a:rPr>
+              <a:t>07  El jurado entra con rol Auditor.</a:t>
+            </a:r>
+          </a:p>
+        </p:txBody>
+      </p:sp>
+      <p:sp>
+        <p:nvSpPr>
+          <p:cNvPr id="27" name="TextBox 26"/>
+          <p:cNvSpPr txBox="1"/>
+          <p:nvPr/>
+        </p:nvSpPr>
+        <p:spPr>
+          <a:xfrm>
+            <a:off x="4937760" y="5289804"/>
+            <a:ext cx="6537960" cy="219456"/>
+          </a:xfrm>
+          <a:prstGeom prst="rect">
+            <a:avLst/>
+          </a:prstGeom>
+          <a:noFill/>
+        </p:spPr>
+        <p:txBody>
+          <a:bodyPr wrap="square" anchor="t" lIns="0" rIns="0" tIns="0" bIns="0">
+            <a:spAutoFit/>
+          </a:bodyPr>
+          <a:lstStyle/>
+          <a:p>
+            <a:pPr algn="l">
+              <a:spcAft>
+                <a:spcPts val="0"/>
+              </a:spcAft>
+            </a:pPr>
+            <a:r>
+              <a:rPr sz="1260" b="0" i="0">
+                <a:solidFill>
+                  <a:srgbClr val="FFFFFF"/>
+                </a:solidFill>
+                <a:latin typeface="Open Sans"/>
+              </a:rPr>
+              <a:t>08  Modo solo lectura: ver todo sin alterar datos.</a:t>
+            </a:r>
+          </a:p>
+        </p:txBody>
+      </p:sp>
+      <p:sp>
+        <p:nvSpPr>
+          <p:cNvPr id="28" name="TextBox 27"/>
+          <p:cNvSpPr txBox="1"/>
+          <p:nvPr/>
+        </p:nvSpPr>
+        <p:spPr>
+          <a:xfrm>
+            <a:off x="4937760" y="5504688"/>
+            <a:ext cx="6537960" cy="219456"/>
+          </a:xfrm>
+          <a:prstGeom prst="rect">
+            <a:avLst/>
+          </a:prstGeom>
+          <a:noFill/>
+        </p:spPr>
+        <p:txBody>
+          <a:bodyPr wrap="square" anchor="t" lIns="0" rIns="0" tIns="0" bIns="0">
+            <a:spAutoFit/>
+          </a:bodyPr>
+          <a:lstStyle/>
+          <a:p>
+            <a:pPr algn="l">
+              <a:spcAft>
+                <a:spcPts val="0"/>
+              </a:spcAft>
+            </a:pPr>
+            <a:r>
+              <a:rPr sz="1260" b="0" i="0">
+                <a:solidFill>
+                  <a:srgbClr val="FFFFFF"/>
+                </a:solidFill>
+                <a:latin typeface="Open Sans"/>
+              </a:rPr>
+              <a:t>09  El servidor bloquea cualquier intento de edición.</a:t>
+            </a:r>
+          </a:p>
+        </p:txBody>
+      </p:sp>
+      <p:sp>
+        <p:nvSpPr>
+          <p:cNvPr id="29" name="TextBox 28"/>
+          <p:cNvSpPr txBox="1"/>
+          <p:nvPr/>
+        </p:nvSpPr>
+        <p:spPr>
+          <a:xfrm>
+            <a:off x="4937760" y="5719571"/>
+            <a:ext cx="6537960" cy="219456"/>
+          </a:xfrm>
+          <a:prstGeom prst="rect">
+            <a:avLst/>
+          </a:prstGeom>
+          <a:noFill/>
+        </p:spPr>
+        <p:txBody>
+          <a:bodyPr wrap="square" anchor="t" lIns="0" rIns="0" tIns="0" bIns="0">
+            <a:spAutoFit/>
+          </a:bodyPr>
+          <a:lstStyle/>
+          <a:p>
+            <a:pPr algn="l">
+              <a:spcAft>
+                <a:spcPts val="0"/>
+              </a:spcAft>
+            </a:pPr>
+            <a:r>
+              <a:rPr sz="1260" b="0" i="0">
+                <a:solidFill>
+                  <a:srgbClr val="FFFFFF"/>
+                </a:solidFill>
+                <a:latin typeface="Open Sans"/>
+              </a:rPr>
+              <a:t>10  La cuenta se desactiva al cerrar la evaluación.</a:t>
+            </a:r>
+          </a:p>
+        </p:txBody>
+      </p:sp>
+    </p:spTree>
+  </p:cSld>
+  <p:clrMapOvr>
+    <a:masterClrMapping/>
+  </p:clrMapOvr>
+  <p:transition spd="med">
+    <p:fade/>
+  </p:transition>
 </p:sld>
 </file>
 
@@ -16328,4 +18458,324 @@
   </a:objectDefaults>
   <a:extraClrSchemeLst/>
 </a:theme>
+</file>
+
+<file path=ppt/theme/theme2.xml><?xml version="1.0" encoding="utf-8"?>
+<a:theme xmlns:a="http://schemas.openxmlformats.org/drawingml/2006/main" name="Office Theme">
+  <a:themeElements>
+    <a:clrScheme name="Office">
+      <a:dk1>
+        <a:sysClr val="windowText" lastClr="000000"/>
+      </a:dk1>
+      <a:lt1>
+        <a:sysClr val="window" lastClr="FFFFFF"/>
+      </a:lt1>
+      <a:dk2>
+        <a:srgbClr val="1F497D"/>
+      </a:dk2>
+      <a:lt2>
+        <a:srgbClr val="EEECE1"/>
+      </a:lt2>
+      <a:accent1>
+        <a:srgbClr val="4F81BD"/>
+      </a:accent1>
+      <a:accent2>
+        <a:srgbClr val="C0504D"/>
+      </a:accent2>
+      <a:accent3>
+        <a:srgbClr val="9BBB59"/>
+      </a:accent3>
+      <a:accent4>
+        <a:srgbClr val="8064A2"/>
+      </a:accent4>
+      <a:accent5>
+        <a:srgbClr val="4BACC6"/>
+      </a:accent5>
+      <a:accent6>
+        <a:srgbClr val="F79646"/>
+      </a:accent6>
+      <a:hlink>
+        <a:srgbClr val="0000FF"/>
+      </a:hlink>
+      <a:folHlink>
+        <a:srgbClr val="800080"/>
+      </a:folHlink>
+    </a:clrScheme>
+    <a:fontScheme name="Office">
+      <a:majorFont>
+        <a:latin typeface="Calibri"/>
+        <a:ea typeface=""/>
+        <a:cs typeface=""/>
+        <a:font script="Jpan" typeface="ＭＳ Ｐゴシック"/>
+        <a:font script="Hang" typeface="맑은 고딕"/>
+        <a:font script="Hans" typeface="宋体"/>
+        <a:font script="Hant" typeface="新細明體"/>
+        <a:font script="Arab" typeface="Times New Roman"/>
+        <a:font script="Hebr" typeface="Times New Roman"/>
+        <a:font script="Thai" typeface="Angsana New"/>
+        <a:font script="Ethi" typeface="Nyala"/>
+        <a:font script="Beng" typeface="Vrinda"/>
+        <a:font script="Gujr" typeface="Shruti"/>
+        <a:font script="Khmr" typeface="MoolBoran"/>
+        <a:font script="Knda" typeface="Tunga"/>
+        <a:font script="Guru" typeface="Raavi"/>
+        <a:font script="Cans" typeface="Euphemia"/>
+        <a:font script="Cher" typeface="Plantagenet Cherokee"/>
+        <a:font script="Yiii" typeface="Microsoft Yi Baiti"/>
+        <a:font script="Tibt" typeface="Microsoft Himalaya"/>
+        <a:font script="Thaa" typeface="MV Boli"/>
+        <a:font script="Deva" typeface="Mangal"/>
+        <a:font script="Telu" typeface="Gautami"/>
+        <a:font script="Taml" typeface="Latha"/>
+        <a:font script="Syrc" typeface="Estrangelo Edessa"/>
+        <a:font script="Orya" typeface="Kalinga"/>
+        <a:font script="Mlym" typeface="Kartika"/>
+        <a:font script="Laoo" typeface="DokChampa"/>
+        <a:font script="Sinh" typeface="Iskoola Pota"/>
+        <a:font script="Mong" typeface="Mongolian Baiti"/>
+        <a:font script="Viet" typeface="Times New Roman"/>
+        <a:font script="Uigh" typeface="Microsoft Uighur"/>
+        <a:font script="Geor" typeface="Sylfaen"/>
+      </a:majorFont>
+      <a:minorFont>
+        <a:latin typeface="Calibri"/>
+        <a:ea typeface=""/>
+        <a:cs typeface=""/>
+        <a:font script="Jpan" typeface="ＭＳ Ｐゴシック"/>
+        <a:font script="Hang" typeface="맑은 고딕"/>
+        <a:font script="Hans" typeface="宋体"/>
+        <a:font script="Hant" typeface="新細明體"/>
+        <a:font script="Arab" typeface="Arial"/>
+        <a:font script="Hebr" typeface="Arial"/>
+        <a:font script="Thai" typeface="Cordia New"/>
+        <a:font script="Ethi" typeface="Nyala"/>
+        <a:font script="Beng" typeface="Vrinda"/>
+        <a:font script="Gujr" typeface="Shruti"/>
+        <a:font script="Khmr" typeface="DaunPenh"/>
+        <a:font script="Knda" typeface="Tunga"/>
+        <a:font script="Guru" typeface="Raavi"/>
+        <a:font script="Cans" typeface="Euphemia"/>
+        <a:font script="Cher" typeface="Plantagenet Cherokee"/>
+        <a:font script="Yiii" typeface="Microsoft Yi Baiti"/>
+        <a:font script="Tibt" typeface="Microsoft Himalaya"/>
+        <a:font script="Thaa" typeface="MV Boli"/>
+        <a:font script="Deva" typeface="Mangal"/>
+        <a:font script="Telu" typeface="Gautami"/>
+        <a:font script="Taml" typeface="Latha"/>
+        <a:font script="Syrc" typeface="Estrangelo Edessa"/>
+        <a:font script="Orya" typeface="Kalinga"/>
+        <a:font script="Mlym" typeface="Kartika"/>
+        <a:font script="Laoo" typeface="DokChampa"/>
+        <a:font script="Sinh" typeface="Iskoola Pota"/>
+        <a:font script="Mong" typeface="Mongolian Baiti"/>
+        <a:font script="Viet" typeface="Arial"/>
+        <a:font script="Uigh" typeface="Microsoft Uighur"/>
+        <a:font script="Geor" typeface="Sylfaen"/>
+      </a:minorFont>
+    </a:fontScheme>
+    <a:fmtScheme name="Office">
+      <a:fillStyleLst>
+        <a:solidFill>
+          <a:schemeClr val="phClr"/>
+        </a:solidFill>
+        <a:gradFill rotWithShape="1">
+          <a:gsLst>
+            <a:gs pos="0">
+              <a:schemeClr val="phClr">
+                <a:tint val="50000"/>
+                <a:satMod val="300000"/>
+              </a:schemeClr>
+            </a:gs>
+            <a:gs pos="35000">
+              <a:schemeClr val="phClr">
+                <a:tint val="37000"/>
+                <a:satMod val="300000"/>
+              </a:schemeClr>
+            </a:gs>
+            <a:gs pos="100000">
+              <a:schemeClr val="phClr">
+                <a:tint val="15000"/>
+                <a:satMod val="350000"/>
+              </a:schemeClr>
+            </a:gs>
+          </a:gsLst>
+          <a:lin ang="16200000" scaled="1"/>
+        </a:gradFill>
+        <a:gradFill rotWithShape="1">
+          <a:gsLst>
+            <a:gs pos="0">
+              <a:schemeClr val="phClr">
+                <a:tint val="100000"/>
+                <a:shade val="100000"/>
+                <a:satMod val="130000"/>
+              </a:schemeClr>
+            </a:gs>
+            <a:gs pos="100000">
+              <a:schemeClr val="phClr">
+                <a:tint val="50000"/>
+                <a:shade val="100000"/>
+                <a:satMod val="350000"/>
+              </a:schemeClr>
+            </a:gs>
+          </a:gsLst>
+          <a:lin ang="16200000" scaled="0"/>
+        </a:gradFill>
+      </a:fillStyleLst>
+      <a:lnStyleLst>
+        <a:ln w="9525" cap="flat" cmpd="sng" algn="ctr">
+          <a:solidFill>
+            <a:schemeClr val="phClr">
+              <a:shade val="95000"/>
+              <a:satMod val="105000"/>
+            </a:schemeClr>
+          </a:solidFill>
+          <a:prstDash val="solid"/>
+        </a:ln>
+        <a:ln w="25400" cap="flat" cmpd="sng" algn="ctr">
+          <a:solidFill>
+            <a:schemeClr val="phClr"/>
+          </a:solidFill>
+          <a:prstDash val="solid"/>
+        </a:ln>
+        <a:ln w="38100" cap="flat" cmpd="sng" algn="ctr">
+          <a:solidFill>
+            <a:schemeClr val="phClr"/>
+          </a:solidFill>
+          <a:prstDash val="solid"/>
+        </a:ln>
+      </a:lnStyleLst>
+      <a:effectStyleLst>
+        <a:effectStyle>
+          <a:effectLst>
+            <a:outerShdw blurRad="40000" dist="20000" dir="5400000" rotWithShape="0">
+              <a:srgbClr val="000000">
+                <a:alpha val="38000"/>
+              </a:srgbClr>
+            </a:outerShdw>
+          </a:effectLst>
+        </a:effectStyle>
+        <a:effectStyle>
+          <a:effectLst>
+            <a:outerShdw blurRad="40000" dist="23000" dir="5400000" rotWithShape="0">
+              <a:srgbClr val="000000">
+                <a:alpha val="35000"/>
+              </a:srgbClr>
+            </a:outerShdw>
+          </a:effectLst>
+        </a:effectStyle>
+        <a:effectStyle>
+          <a:effectLst>
+            <a:outerShdw blurRad="40000" dist="23000" dir="5400000" rotWithShape="0">
+              <a:srgbClr val="000000">
+                <a:alpha val="35000"/>
+              </a:srgbClr>
+            </a:outerShdw>
+          </a:effectLst>
+          <a:scene3d>
+            <a:camera prst="orthographicFront">
+              <a:rot lat="0" lon="0" rev="0"/>
+            </a:camera>
+            <a:lightRig rig="threePt" dir="t">
+              <a:rot lat="0" lon="0" rev="1200000"/>
+            </a:lightRig>
+          </a:scene3d>
+          <a:sp3d>
+            <a:bevelT w="63500" h="25400"/>
+          </a:sp3d>
+        </a:effectStyle>
+      </a:effectStyleLst>
+      <a:bgFillStyleLst>
+        <a:solidFill>
+          <a:schemeClr val="phClr"/>
+        </a:solidFill>
+        <a:gradFill rotWithShape="1">
+          <a:gsLst>
+            <a:gs pos="0">
+              <a:schemeClr val="phClr">
+                <a:tint val="40000"/>
+                <a:satMod val="350000"/>
+              </a:schemeClr>
+            </a:gs>
+            <a:gs pos="40000">
+              <a:schemeClr val="phClr">
+                <a:tint val="45000"/>
+                <a:shade val="99000"/>
+                <a:satMod val="350000"/>
+              </a:schemeClr>
+            </a:gs>
+            <a:gs pos="100000">
+              <a:schemeClr val="phClr">
+                <a:shade val="20000"/>
+                <a:satMod val="255000"/>
+              </a:schemeClr>
+            </a:gs>
+          </a:gsLst>
+          <a:path path="circle">
+            <a:fillToRect l="50000" t="-80000" r="50000" b="180000"/>
+          </a:path>
+        </a:gradFill>
+        <a:gradFill rotWithShape="1">
+          <a:gsLst>
+            <a:gs pos="0">
+              <a:schemeClr val="phClr">
+                <a:tint val="80000"/>
+                <a:satMod val="300000"/>
+              </a:schemeClr>
+            </a:gs>
+            <a:gs pos="100000">
+              <a:schemeClr val="phClr">
+                <a:shade val="30000"/>
+                <a:satMod val="200000"/>
+              </a:schemeClr>
+            </a:gs>
+          </a:gsLst>
+          <a:path path="circle">
+            <a:fillToRect l="50000" t="50000" r="50000" b="50000"/>
+          </a:path>
+        </a:gradFill>
+      </a:bgFillStyleLst>
+    </a:fmtScheme>
+  </a:themeElements>
+  <a:objectDefaults>
+    <a:spDef>
+      <a:spPr/>
+      <a:bodyPr/>
+      <a:lstStyle/>
+      <a:style>
+        <a:lnRef idx="1">
+          <a:schemeClr val="accent1"/>
+        </a:lnRef>
+        <a:fillRef idx="3">
+          <a:schemeClr val="accent1"/>
+        </a:fillRef>
+        <a:effectRef idx="2">
+          <a:schemeClr val="accent1"/>
+        </a:effectRef>
+        <a:fontRef idx="minor">
+          <a:schemeClr val="lt1"/>
+        </a:fontRef>
+      </a:style>
+    </a:spDef>
+    <a:lnDef>
+      <a:spPr/>
+      <a:bodyPr/>
+      <a:lstStyle/>
+      <a:style>
+        <a:lnRef idx="2">
+          <a:schemeClr val="accent1"/>
+        </a:lnRef>
+        <a:fillRef idx="0">
+          <a:schemeClr val="accent1"/>
+        </a:fillRef>
+        <a:effectRef idx="1">
+          <a:schemeClr val="accent1"/>
+        </a:effectRef>
+        <a:fontRef idx="minor">
+          <a:schemeClr val="tx1"/>
+        </a:fontRef>
+      </a:style>
+    </a:lnDef>
+  </a:objectDefaults>
+  <a:extraClrSchemeLst/>
+</a:theme>
 </file>
</xml_diff>